<commit_message>
docs(presentation): update SIH2026 PPTX template with sovereign solver content
</commit_message>
<xml_diff>
--- a/SIH2026-IDEA-Presentation-Format.pptx
+++ b/SIH2026-IDEA-Presentation-Format.pptx
@@ -5825,107 +5825,155 @@
           </a:bodyPr>
           <a:lstStyle/>
           <a:p>
+            <a:pPr>
+              <a:spcAft>
+                <a:spcPts val="600"/>
+              </a:spcAft>
+            </a:pPr>
+            <a:r>
+              <a:rPr sz="1600" b="1">
+                <a:solidFill>
+                  <a:srgbClr val="1B365D"/>
+                </a:solidFill>
+                <a:latin typeface="Arial"/>
+              </a:rPr>
+              <a:t>Problem Statement ID – </a:t>
+            </a:r>
+            <a:r>
+              <a:rPr sz="1500" b="0">
+                <a:solidFill>
+                  <a:srgbClr val="333333"/>
+                </a:solidFill>
+                <a:latin typeface="Arial"/>
+              </a:rPr>
+              <a:t>SIH1638</a:t>
+            </a:r>
             <a:endParaRPr lang="en-US" dirty="0"/>
           </a:p>
           <a:p>
-            <a:pPr marL="285750" indent="-285750" algn="just">
-              <a:lnSpc>
-                <a:spcPct val="200000"/>
-              </a:lnSpc>
-              <a:buFont typeface="Arial" panose="020B0604020202020204" pitchFamily="34" charset="0"/>
-              <a:buChar char="•"/>
-            </a:pPr>
-            <a:r>
-              <a:rPr lang="en-US" sz="2400" b="1" dirty="0">
-                <a:latin typeface="Arial" panose="020B0604020202020204" pitchFamily="34" charset="0"/>
-                <a:cs typeface="Arial" panose="020B0604020202020204" pitchFamily="34" charset="0"/>
+            <a:pPr>
+              <a:spcAft>
+                <a:spcPts val="600"/>
+              </a:spcAft>
+            </a:pPr>
+            <a:r>
+              <a:rPr sz="1600" b="1">
+                <a:solidFill>
+                  <a:srgbClr val="1B365D"/>
+                </a:solidFill>
+                <a:latin typeface="Arial"/>
               </a:rPr>
-              <a:t>Problem Statement ID –</a:t>
-            </a:r>
-          </a:p>
-          <a:p>
-            <a:pPr marL="285750" indent="-285750" algn="just">
-              <a:lnSpc>
-                <a:spcPct val="200000"/>
-              </a:lnSpc>
-              <a:buFont typeface="Arial" panose="020B0604020202020204" pitchFamily="34" charset="0"/>
-              <a:buChar char="•"/>
-            </a:pPr>
-            <a:r>
-              <a:rPr lang="en-US" sz="2400" b="1" dirty="0">
-                <a:latin typeface="Arial" panose="020B0604020202020204" pitchFamily="34" charset="0"/>
-                <a:cs typeface="Arial" panose="020B0604020202020204" pitchFamily="34" charset="0"/>
+              <a:t>Problem Statement Title – </a:t>
+            </a:r>
+            <a:r>
+              <a:rPr sz="1500" b="0">
+                <a:solidFill>
+                  <a:srgbClr val="333333"/>
+                </a:solidFill>
+                <a:latin typeface="Arial"/>
               </a:rPr>
-              <a:t>Problem Statement Title-</a:t>
-            </a:r>
-          </a:p>
-          <a:p>
-            <a:pPr marL="285750" indent="-285750" algn="just">
-              <a:lnSpc>
-                <a:spcPct val="200000"/>
-              </a:lnSpc>
-              <a:buFont typeface="Arial" panose="020B0604020202020204" pitchFamily="34" charset="0"/>
-              <a:buChar char="•"/>
-            </a:pPr>
-            <a:r>
-              <a:rPr lang="en-US" sz="2400" b="1" dirty="0">
-                <a:latin typeface="Arial" panose="020B0604020202020204" pitchFamily="34" charset="0"/>
-                <a:cs typeface="Arial" panose="020B0604020202020204" pitchFamily="34" charset="0"/>
+              <a:t>Development of a Sovereign Mathematical Optimization Solver Core</a:t>
+            </a:r>
+          </a:p>
+          <a:p>
+            <a:pPr>
+              <a:spcAft>
+                <a:spcPts val="600"/>
+              </a:spcAft>
+            </a:pPr>
+            <a:r>
+              <a:rPr sz="1600" b="1">
+                <a:solidFill>
+                  <a:srgbClr val="1B365D"/>
+                </a:solidFill>
+                <a:latin typeface="Arial"/>
               </a:rPr>
-              <a:t>Theme-</a:t>
-            </a:r>
-          </a:p>
-          <a:p>
-            <a:pPr marL="285750" indent="-285750" algn="just">
-              <a:lnSpc>
-                <a:spcPct val="200000"/>
-              </a:lnSpc>
-              <a:buFont typeface="Arial" panose="020B0604020202020204" pitchFamily="34" charset="0"/>
-              <a:buChar char="•"/>
-            </a:pPr>
-            <a:r>
-              <a:rPr lang="en-US" sz="2400" b="1" dirty="0">
-                <a:latin typeface="Arial" panose="020B0604020202020204" pitchFamily="34" charset="0"/>
-                <a:cs typeface="Arial" panose="020B0604020202020204" pitchFamily="34" charset="0"/>
+              <a:t>Theme – </a:t>
+            </a:r>
+            <a:r>
+              <a:rPr sz="1500" b="0">
+                <a:solidFill>
+                  <a:srgbClr val="333333"/>
+                </a:solidFill>
+                <a:latin typeface="Arial"/>
               </a:rPr>
-              <a:t>PS Category- Software/Hardware</a:t>
-            </a:r>
-          </a:p>
-          <a:p>
-            <a:pPr marL="285750" indent="-285750" algn="just">
-              <a:lnSpc>
-                <a:spcPct val="200000"/>
-              </a:lnSpc>
-              <a:buFont typeface="Arial" panose="020B0604020202020204" pitchFamily="34" charset="0"/>
-              <a:buChar char="•"/>
-            </a:pPr>
-            <a:r>
-              <a:rPr lang="en-US" sz="2400" b="1" dirty="0">
-                <a:latin typeface="Arial" panose="020B0604020202020204" pitchFamily="34" charset="0"/>
-                <a:cs typeface="Arial" panose="020B0604020202020204" pitchFamily="34" charset="0"/>
+              <a:t>Strategic Infrastructure &amp; Computational Systems</a:t>
+            </a:r>
+          </a:p>
+          <a:p>
+            <a:pPr>
+              <a:spcAft>
+                <a:spcPts val="600"/>
+              </a:spcAft>
+            </a:pPr>
+            <a:r>
+              <a:rPr sz="1600" b="1">
+                <a:solidFill>
+                  <a:srgbClr val="1B365D"/>
+                </a:solidFill>
+                <a:latin typeface="Arial"/>
               </a:rPr>
-              <a:t>Team ID-</a:t>
-            </a:r>
-          </a:p>
-          <a:p>
-            <a:pPr marL="285750" indent="-285750" algn="just">
-              <a:lnSpc>
-                <a:spcPct val="200000"/>
-              </a:lnSpc>
-              <a:buFont typeface="Arial" panose="020B0604020202020204" pitchFamily="34" charset="0"/>
-              <a:buChar char="•"/>
-            </a:pPr>
-            <a:r>
-              <a:rPr lang="en-US" sz="2400" b="1" dirty="0">
-                <a:latin typeface="Arial" panose="020B0604020202020204" pitchFamily="34" charset="0"/>
-                <a:cs typeface="Arial" panose="020B0604020202020204" pitchFamily="34" charset="0"/>
+              <a:t>PS Category – </a:t>
+            </a:r>
+            <a:r>
+              <a:rPr sz="1500" b="0">
+                <a:solidFill>
+                  <a:srgbClr val="333333"/>
+                </a:solidFill>
+                <a:latin typeface="Arial"/>
               </a:rPr>
-              <a:t>Team Name (Registered on portal)</a:t>
-            </a:r>
-            <a:endParaRPr lang="en-IN" sz="2400" b="1" dirty="0">
-              <a:latin typeface="Arial" panose="020B0604020202020204" pitchFamily="34" charset="0"/>
-              <a:cs typeface="Arial" panose="020B0604020202020204" pitchFamily="34" charset="0"/>
-            </a:endParaRPr>
+              <a:t>Software</a:t>
+            </a:r>
+          </a:p>
+          <a:p>
+            <a:pPr>
+              <a:spcAft>
+                <a:spcPts val="600"/>
+              </a:spcAft>
+            </a:pPr>
+            <a:r>
+              <a:rPr sz="1600" b="1">
+                <a:solidFill>
+                  <a:srgbClr val="1B365D"/>
+                </a:solidFill>
+                <a:latin typeface="Arial"/>
+              </a:rPr>
+              <a:t>Team ID – </a:t>
+            </a:r>
+            <a:r>
+              <a:rPr sz="1500" b="0">
+                <a:solidFill>
+                  <a:srgbClr val="333333"/>
+                </a:solidFill>
+                <a:latin typeface="Arial"/>
+              </a:rPr>
+              <a:t>[Registered Team ID]</a:t>
+            </a:r>
+          </a:p>
+          <a:p>
+            <a:pPr>
+              <a:spcAft>
+                <a:spcPts val="600"/>
+              </a:spcAft>
+            </a:pPr>
+            <a:r>
+              <a:rPr sz="1600" b="1">
+                <a:solidFill>
+                  <a:srgbClr val="1B365D"/>
+                </a:solidFill>
+                <a:latin typeface="Arial"/>
+              </a:rPr>
+              <a:t>Team Name – </a:t>
+            </a:r>
+            <a:r>
+              <a:rPr sz="1500" b="0">
+                <a:solidFill>
+                  <a:srgbClr val="333333"/>
+                </a:solidFill>
+                <a:latin typeface="Arial"/>
+              </a:rPr>
+              <a:t>Sovereign Solvers (AryanMotiani / dweep-desai)</a:t>
+            </a:r>
           </a:p>
         </p:txBody>
       </p:sp>
@@ -6059,32 +6107,19 @@
           </a:xfrm>
         </p:spPr>
         <p:txBody>
-          <a:bodyPr/>
+          <a:bodyPr wrap="square"/>
           <a:lstStyle/>
           <a:p>
-            <a:pPr eaLnBrk="1" hangingPunct="1"/>
-            <a:r>
-              <a:rPr lang="en-US" sz="3600" b="1" dirty="0">
-                <a:latin typeface="Times New Roman" panose="02020603050405020304" pitchFamily="18" charset="0"/>
-                <a:ea typeface="ＭＳ Ｐゴシック" pitchFamily="1" charset="-128"/>
-                <a:cs typeface="Times New Roman" panose="02020603050405020304" pitchFamily="18" charset="0"/>
-              </a:rPr>
-              <a:t/>
-            </a:r>
-            <a:br>
-              <a:rPr lang="en-US" sz="3600" b="1" dirty="0">
-                <a:latin typeface="Times New Roman" panose="02020603050405020304" pitchFamily="18" charset="0"/>
-                <a:ea typeface="ＭＳ Ｐゴシック" pitchFamily="1" charset="-128"/>
-                <a:cs typeface="Times New Roman" panose="02020603050405020304" pitchFamily="18" charset="0"/>
-              </a:rPr>
-            </a:br>
-            <a:r>
-              <a:rPr lang="en-US" sz="3600" b="1" dirty="0">
-                <a:latin typeface="Times New Roman" panose="02020603050405020304" pitchFamily="18" charset="0"/>
-                <a:ea typeface="ＭＳ Ｐゴシック" pitchFamily="1" charset="-128"/>
-                <a:cs typeface="Times New Roman" panose="02020603050405020304" pitchFamily="18" charset="0"/>
-              </a:rPr>
-              <a:t>IDEA TITLE</a:t>
+            <a:pPr eaLnBrk="1" hangingPunct="1">
+              <a:defRPr sz="2800" b="1">
+                <a:solidFill>
+                  <a:srgbClr val="1B365D"/>
+                </a:solidFill>
+                <a:latin typeface="Times New Roman"/>
+              </a:defRPr>
+            </a:pPr>
+            <a:r>
+              <a:t>SOVEREIGN OPTIMIZATION SOLVER CORE</a:t>
             </a:r>
           </a:p>
         </p:txBody>
@@ -6099,8 +6134,8 @@
         </p:nvSpPr>
         <p:spPr bwMode="auto">
           <a:xfrm>
-            <a:off x="-1" y="2064921"/>
-            <a:ext cx="12191999" cy="2492990"/>
+            <a:off x="548640" y="1280160"/>
+            <a:ext cx="10972800" cy="4572000"/>
           </a:xfrm>
           <a:prstGeom prst="rect">
             <a:avLst/>
@@ -6120,18 +6155,23 @@
           <a:lstStyle/>
           <a:p>
             <a:pPr marL="342900" indent="-342900">
+              <a:spcBef>
+                <a:spcPts val="400"/>
+              </a:spcBef>
+              <a:spcAft>
+                <a:spcPts val="200"/>
+              </a:spcAft>
               <a:buFont typeface="Wingdings" panose="05000000000000000000" pitchFamily="2" charset="2"/>
               <a:buChar char="v"/>
-            </a:pPr>
-            <a:r>
-              <a:rPr lang="en-US" sz="3200" b="1" u="sng" dirty="0">
-                <a:solidFill>
-                  <a:schemeClr val="tx2"/>
-                </a:solidFill>
-                <a:latin typeface="Arial" pitchFamily="34" charset="0"/>
-                <a:cs typeface="Arial" pitchFamily="34" charset="0"/>
-              </a:rPr>
-              <a:t>Proposed Solution (Describe your Idea/Solution/Prototype)</a:t>
+              <a:defRPr sz="1300" b="1">
+                <a:solidFill>
+                  <a:srgbClr val="005691"/>
+                </a:solidFill>
+                <a:latin typeface="Arial"/>
+              </a:defRPr>
+            </a:pPr>
+            <a:r>
+              <a:t>1. Proposed Solution (Idea / Prototype Overview)</a:t>
             </a:r>
             <a:endParaRPr lang="en-US" sz="3200" u="sng" dirty="0">
               <a:solidFill>
@@ -6142,68 +6182,204 @@
             </a:endParaRPr>
           </a:p>
           <a:p>
-            <a:pPr marL="342900" indent="-342900">
-              <a:buFont typeface="Arial" panose="020B0604020202020204" pitchFamily="34" charset="0"/>
-              <a:buChar char="•"/>
-            </a:pPr>
-            <a:endParaRPr lang="en-US" sz="2000" u="sng" dirty="0">
-              <a:solidFill>
-                <a:schemeClr val="tx2"/>
-              </a:solidFill>
-              <a:latin typeface="Arial" pitchFamily="34" charset="0"/>
-              <a:cs typeface="Arial" pitchFamily="34" charset="0"/>
-            </a:endParaRPr>
-          </a:p>
-          <a:p>
-            <a:pPr marL="342900" indent="-342900">
-              <a:buFont typeface="Arial" panose="020B0604020202020204" pitchFamily="34" charset="0"/>
-              <a:buChar char="•"/>
-            </a:pPr>
-            <a:endParaRPr lang="en-US" sz="2000" u="sng" dirty="0">
-              <a:solidFill>
-                <a:schemeClr val="tx2"/>
-              </a:solidFill>
-              <a:latin typeface="Arial" pitchFamily="34" charset="0"/>
-              <a:cs typeface="Arial" pitchFamily="34" charset="0"/>
-            </a:endParaRPr>
-          </a:p>
-          <a:p>
-            <a:pPr marL="342900" indent="-342900" algn="just">
-              <a:buFont typeface="Arial" panose="020B0604020202020204" pitchFamily="34" charset="0"/>
-              <a:buChar char="•"/>
-            </a:pPr>
-            <a:r>
-              <a:rPr lang="en-US" sz="2800" dirty="0">
-                <a:latin typeface="Arial" pitchFamily="34" charset="0"/>
-                <a:cs typeface="Arial" pitchFamily="34" charset="0"/>
-              </a:rPr>
-              <a:t>Detailed explanation of the proposed solution</a:t>
-            </a:r>
-          </a:p>
-          <a:p>
-            <a:pPr marL="342900" indent="-342900" algn="just">
-              <a:buFont typeface="Arial" panose="020B0604020202020204" pitchFamily="34" charset="0"/>
-              <a:buChar char="•"/>
-            </a:pPr>
-            <a:r>
-              <a:rPr lang="en-US" sz="2800" dirty="0">
-                <a:latin typeface="Arial" pitchFamily="34" charset="0"/>
-                <a:cs typeface="Arial" pitchFamily="34" charset="0"/>
-              </a:rPr>
-              <a:t> How it addresses the problem</a:t>
-            </a:r>
-          </a:p>
-          <a:p>
-            <a:pPr marL="342900" indent="-342900" algn="just">
-              <a:buFont typeface="Arial" panose="020B0604020202020204" pitchFamily="34" charset="0"/>
-              <a:buChar char="•"/>
-            </a:pPr>
-            <a:r>
-              <a:rPr lang="en-US" sz="2800" dirty="0">
-                <a:latin typeface="Arial" pitchFamily="34" charset="0"/>
-                <a:cs typeface="Arial" pitchFamily="34" charset="0"/>
-              </a:rPr>
-              <a:t>Innovation and uniqueness of the solution </a:t>
+            <a:pPr>
+              <a:spcAft>
+                <a:spcPts val="200"/>
+              </a:spcAft>
+              <a:defRPr sz="1100" b="0">
+                <a:solidFill>
+                  <a:srgbClr val="333333"/>
+                </a:solidFill>
+                <a:latin typeface="Arial"/>
+              </a:defRPr>
+            </a:pPr>
+            <a:r>
+              <a:t>• Built an industrial-grade Sovereign Mathematical Optimization Engine from scratch in Python/NumPy/SciPy without wrapping any foreign commercial (Gurobi, CPLEX) or open-source solvers (HiGHS, SCIP, CBC).</a:t>
+            </a:r>
+          </a:p>
+          <a:p>
+            <a:pPr>
+              <a:spcAft>
+                <a:spcPts val="200"/>
+              </a:spcAft>
+              <a:defRPr sz="1100" b="0">
+                <a:solidFill>
+                  <a:srgbClr val="333333"/>
+                </a:solidFill>
+                <a:latin typeface="Arial"/>
+              </a:defRPr>
+            </a:pPr>
+            <a:r>
+              <a:t>• Delivers complete solver capabilities for Linear Programming (LP), Mixed-Integer LP (MILP), and Quadratic Programming (QP) with native MPS, LP, and QPS format readers.</a:t>
+            </a:r>
+          </a:p>
+          <a:p>
+            <a:pPr>
+              <a:spcBef>
+                <a:spcPts val="400"/>
+              </a:spcBef>
+              <a:spcAft>
+                <a:spcPts val="200"/>
+              </a:spcAft>
+              <a:defRPr sz="1300" b="1">
+                <a:solidFill>
+                  <a:srgbClr val="005691"/>
+                </a:solidFill>
+                <a:latin typeface="Arial"/>
+              </a:defRPr>
+            </a:pPr>
+            <a:r>
+              <a:t>2. Detailed Explanation of the Proposed Solution</a:t>
+            </a:r>
+          </a:p>
+          <a:p>
+            <a:pPr>
+              <a:spcAft>
+                <a:spcPts val="200"/>
+              </a:spcAft>
+              <a:defRPr sz="1100" b="0">
+                <a:solidFill>
+                  <a:srgbClr val="333333"/>
+                </a:solidFill>
+                <a:latin typeface="Arial"/>
+              </a:defRPr>
+            </a:pPr>
+            <a:r>
+              <a:t>• Continuous LP Core: Sparse Revised Simplex with Forrest-Tomlin dynamic LU updates + Mehrotra Predictor-Corrector Interior Point Method (IPM) with basis crossover + Restarted PDHG.</a:t>
+            </a:r>
+          </a:p>
+          <a:p>
+            <a:pPr>
+              <a:spcAft>
+                <a:spcPts val="200"/>
+              </a:spcAft>
+              <a:defRPr sz="1100" b="0">
+                <a:solidFill>
+                  <a:srgbClr val="333333"/>
+                </a:solidFill>
+                <a:latin typeface="Arial"/>
+              </a:defRPr>
+            </a:pPr>
+            <a:r>
+              <a:t>• Mixed-Integer LP Core: Branch-and-Cut with Chvátal-Gomory, MIR, and clique cuts; reliability pseudocost branching; primal heuristics (Feasibility Pump, RINS, diving); and warm-started dual simplex.</a:t>
+            </a:r>
+          </a:p>
+          <a:p>
+            <a:pPr>
+              <a:spcAft>
+                <a:spcPts val="200"/>
+              </a:spcAft>
+              <a:defRPr sz="1100" b="0">
+                <a:solidFill>
+                  <a:srgbClr val="333333"/>
+                </a:solidFill>
+                <a:latin typeface="Arial"/>
+              </a:defRPr>
+            </a:pPr>
+            <a:r>
+              <a:t>• Quadratic Programming (QP): Alternating Direction Method of Multipliers (ADMM) with active-set solution polishing.</a:t>
+            </a:r>
+          </a:p>
+          <a:p>
+            <a:pPr>
+              <a:spcBef>
+                <a:spcPts val="400"/>
+              </a:spcBef>
+              <a:spcAft>
+                <a:spcPts val="200"/>
+              </a:spcAft>
+              <a:defRPr sz="1300" b="1">
+                <a:solidFill>
+                  <a:srgbClr val="005691"/>
+                </a:solidFill>
+                <a:latin typeface="Arial"/>
+              </a:defRPr>
+            </a:pPr>
+            <a:r>
+              <a:t>3. How It Addresses the Problem &amp; National Need</a:t>
+            </a:r>
+          </a:p>
+          <a:p>
+            <a:pPr>
+              <a:spcAft>
+                <a:spcPts val="200"/>
+              </a:spcAft>
+              <a:defRPr sz="1100" b="0">
+                <a:solidFill>
+                  <a:srgbClr val="333333"/>
+                </a:solidFill>
+                <a:latin typeface="Arial"/>
+              </a:defRPr>
+            </a:pPr>
+            <a:r>
+              <a:t>• Breaks critical dependence on expensive foreign licenses across India's refining, power dispatch, logistics, and planning sectors.</a:t>
+            </a:r>
+          </a:p>
+          <a:p>
+            <a:pPr>
+              <a:spcAft>
+                <a:spcPts val="200"/>
+              </a:spcAft>
+              <a:defRPr sz="1100" b="0">
+                <a:solidFill>
+                  <a:srgbClr val="333333"/>
+                </a:solidFill>
+                <a:latin typeface="Arial"/>
+              </a:defRPr>
+            </a:pPr>
+            <a:r>
+              <a:t>• Provides complete mathematical transparency, preventing proprietary vendor lock-in and geopolitical software embargoes on national infrastructure.</a:t>
+            </a:r>
+          </a:p>
+          <a:p>
+            <a:pPr>
+              <a:spcBef>
+                <a:spcPts val="400"/>
+              </a:spcBef>
+              <a:spcAft>
+                <a:spcPts val="200"/>
+              </a:spcAft>
+              <a:defRPr sz="1300" b="1">
+                <a:solidFill>
+                  <a:srgbClr val="005691"/>
+                </a:solidFill>
+                <a:latin typeface="Arial"/>
+              </a:defRPr>
+            </a:pPr>
+            <a:r>
+              <a:t>4. Innovation &amp; Uniqueness of the Solution</a:t>
+            </a:r>
+          </a:p>
+          <a:p>
+            <a:pPr>
+              <a:spcAft>
+                <a:spcPts val="200"/>
+              </a:spcAft>
+              <a:defRPr sz="1100" b="0">
+                <a:solidFill>
+                  <a:srgbClr val="333333"/>
+                </a:solidFill>
+                <a:latin typeface="Arial"/>
+              </a:defRPr>
+            </a:pPr>
+            <a:r>
+              <a:t>• First Sovereign GPU-Resident LP Engine (pdhg_gpu): Accelerates restarted PDHG using CuPy/CUDA and Apple Metal (MPS), unlocking 3x–7x speedup on massive industrial models (&gt;100k variables).</a:t>
+            </a:r>
+          </a:p>
+          <a:p>
+            <a:pPr>
+              <a:spcAft>
+                <a:spcPts val="200"/>
+              </a:spcAft>
+              <a:defRPr sz="1100" b="0">
+                <a:solidFill>
+                  <a:srgbClr val="333333"/>
+                </a:solidFill>
+                <a:latin typeface="Arial"/>
+              </a:defRPr>
+            </a:pPr>
+            <a:r>
+              <a:t>• High Numerical Robustness: Integrated Ruiz equilibration scaling, Harris two-pass ratio test, and Bland anti-cycling safeguards.</a:t>
             </a:r>
           </a:p>
         </p:txBody>
@@ -6321,10 +6497,16 @@
           <a:bodyPr rtlCol="0" anchor="ctr"/>
           <a:lstStyle/>
           <a:p>
-            <a:pPr algn="ctr"/>
-            <a:r>
-              <a:rPr lang="en-US" dirty="0"/>
-              <a:t>Your Team Name</a:t>
+            <a:pPr algn="ctr">
+              <a:defRPr sz="1100" b="1">
+                <a:solidFill>
+                  <a:srgbClr val="FFFFFF"/>
+                </a:solidFill>
+                <a:latin typeface="Arial"/>
+              </a:defRPr>
+            </a:pPr>
+            <a:r>
+              <a:t>Sovereign Solvers</a:t>
             </a:r>
             <a:endParaRPr lang="en-IN" dirty="0"/>
           </a:p>
@@ -6461,17 +6643,19 @@
         </p:nvSpPr>
         <p:spPr/>
         <p:txBody>
-          <a:bodyPr/>
+          <a:bodyPr wrap="square"/>
           <a:lstStyle/>
           <a:p>
-            <a:pPr eaLnBrk="1" hangingPunct="1"/>
-            <a:r>
-              <a:rPr lang="en-US" sz="3600" b="1" dirty="0">
-                <a:latin typeface="Times New Roman" panose="02020603050405020304" pitchFamily="18" charset="0"/>
-                <a:ea typeface="ＭＳ Ｐゴシック" pitchFamily="1" charset="-128"/>
-                <a:cs typeface="Times New Roman" panose="02020603050405020304" pitchFamily="18" charset="0"/>
-              </a:rPr>
-              <a:t>TECHNICAL APPROACH</a:t>
+            <a:pPr eaLnBrk="1" hangingPunct="1">
+              <a:defRPr sz="2800" b="1">
+                <a:solidFill>
+                  <a:srgbClr val="1B365D"/>
+                </a:solidFill>
+                <a:latin typeface="Times New Roman"/>
+              </a:defRPr>
+            </a:pPr>
+            <a:r>
+              <a:t>TECHNICAL APPROACH &amp; METHODOLOGY</a:t>
             </a:r>
           </a:p>
         </p:txBody>
@@ -6486,8 +6670,8 @@
         </p:nvSpPr>
         <p:spPr bwMode="auto">
           <a:xfrm>
-            <a:off x="609600" y="2533653"/>
-            <a:ext cx="9385300" cy="1815882"/>
+            <a:off x="548640" y="1280160"/>
+            <a:ext cx="10972800" cy="4572000"/>
           </a:xfrm>
           <a:prstGeom prst="rect">
             <a:avLst/>
@@ -6507,28 +6691,189 @@
           <a:lstStyle/>
           <a:p>
             <a:pPr marL="342900" indent="-342900" algn="just">
+              <a:spcBef>
+                <a:spcPts val="400"/>
+              </a:spcBef>
+              <a:spcAft>
+                <a:spcPts val="200"/>
+              </a:spcAft>
               <a:buFont typeface="Arial" panose="020B0604020202020204" pitchFamily="34" charset="0"/>
               <a:buChar char="•"/>
-            </a:pPr>
-            <a:r>
-              <a:rPr lang="en-US" sz="2800" dirty="0">
-                <a:latin typeface="Arial" pitchFamily="34" charset="0"/>
-                <a:cs typeface="Arial" pitchFamily="34" charset="0"/>
-              </a:rPr>
-              <a:t>Technologies to be used (e.g. programming languages, frameworks, hardware)</a:t>
-            </a:r>
-          </a:p>
-          <a:p>
-            <a:pPr marL="342900" indent="-342900" algn="just">
-              <a:buFont typeface="Arial" panose="020B0604020202020204" pitchFamily="34" charset="0"/>
-              <a:buChar char="•"/>
-            </a:pPr>
-            <a:r>
-              <a:rPr lang="en-US" sz="2800" dirty="0">
-                <a:latin typeface="Arial" pitchFamily="34" charset="0"/>
-                <a:cs typeface="Arial" pitchFamily="34" charset="0"/>
-              </a:rPr>
-              <a:t>Methodology and process for implementation (Flow Charts/Images/ working prototype)</a:t>
+              <a:defRPr sz="1300" b="1">
+                <a:solidFill>
+                  <a:srgbClr val="005691"/>
+                </a:solidFill>
+                <a:latin typeface="Arial"/>
+              </a:defRPr>
+            </a:pPr>
+            <a:r>
+              <a:t>1. Technologies &amp; Computational Stack</a:t>
+            </a:r>
+          </a:p>
+          <a:p>
+            <a:pPr>
+              <a:spcAft>
+                <a:spcPts val="200"/>
+              </a:spcAft>
+              <a:defRPr sz="1100" b="0">
+                <a:solidFill>
+                  <a:srgbClr val="333333"/>
+                </a:solidFill>
+                <a:latin typeface="Arial"/>
+              </a:defRPr>
+            </a:pPr>
+            <a:r>
+              <a:t>• Core Engine: Python 3.14, NumPy 2.x (SIMD vectorization), SciPy (sparse CSR/CSC algebra, sparse LU factorization, COLAMD/AMD ordering).</a:t>
+            </a:r>
+          </a:p>
+          <a:p>
+            <a:pPr>
+              <a:spcAft>
+                <a:spcPts val="200"/>
+              </a:spcAft>
+              <a:defRPr sz="1100" b="0">
+                <a:solidFill>
+                  <a:srgbClr val="333333"/>
+                </a:solidFill>
+                <a:latin typeface="Arial"/>
+              </a:defRPr>
+            </a:pPr>
+            <a:r>
+              <a:t>• GPU Acceleration: CuPy (CUDA) &amp; PyTorch (CUDA / Apple Metal MPS) for memory-resident sparse matrix-vector products (SpMV).</a:t>
+            </a:r>
+          </a:p>
+          <a:p>
+            <a:pPr>
+              <a:spcAft>
+                <a:spcPts val="200"/>
+              </a:spcAft>
+              <a:defRPr sz="1100" b="0">
+                <a:solidFill>
+                  <a:srgbClr val="333333"/>
+                </a:solidFill>
+                <a:latin typeface="Arial"/>
+              </a:defRPr>
+            </a:pPr>
+            <a:r>
+              <a:t>• Validation Harness: PyTest test suite (198 passed automated tests), Netlib LP suite, MIPLIB 2017 library, and HiGHS dual-reference cross-checks.</a:t>
+            </a:r>
+          </a:p>
+          <a:p>
+            <a:pPr>
+              <a:spcBef>
+                <a:spcPts val="400"/>
+              </a:spcBef>
+              <a:spcAft>
+                <a:spcPts val="200"/>
+              </a:spcAft>
+              <a:defRPr sz="1300" b="1">
+                <a:solidFill>
+                  <a:srgbClr val="005691"/>
+                </a:solidFill>
+                <a:latin typeface="Arial"/>
+              </a:defRPr>
+            </a:pPr>
+            <a:r>
+              <a:t>2. Algorithmic Pipeline &amp; Architecture</a:t>
+            </a:r>
+          </a:p>
+          <a:p>
+            <a:pPr>
+              <a:spcAft>
+                <a:spcPts val="200"/>
+              </a:spcAft>
+              <a:defRPr sz="1100" b="0">
+                <a:solidFill>
+                  <a:srgbClr val="333333"/>
+                </a:solidFill>
+                <a:latin typeface="Arial"/>
+              </a:defRPr>
+            </a:pPr>
+            <a:r>
+              <a:t>• Multi-Pass Presolve: Implied bound tightening, singleton row substitution, dual fixing, and coefficient strengthening reducing model size by 20%–60%.</a:t>
+            </a:r>
+          </a:p>
+          <a:p>
+            <a:pPr>
+              <a:spcAft>
+                <a:spcPts val="200"/>
+              </a:spcAft>
+              <a:defRPr sz="1100" b="0">
+                <a:solidFill>
+                  <a:srgbClr val="333333"/>
+                </a:solidFill>
+                <a:latin typeface="Arial"/>
+              </a:defRPr>
+            </a:pPr>
+            <a:r>
+              <a:t>• Scaling &amp; Conditioning: Ruiz equilibration row/column normalization mitigating ill-conditioned matrices (condition number &gt; 10^8).</a:t>
+            </a:r>
+          </a:p>
+          <a:p>
+            <a:pPr>
+              <a:spcAft>
+                <a:spcPts val="200"/>
+              </a:spcAft>
+              <a:defRPr sz="1100" b="0">
+                <a:solidFill>
+                  <a:srgbClr val="333333"/>
+                </a:solidFill>
+                <a:latin typeface="Arial"/>
+              </a:defRPr>
+            </a:pPr>
+            <a:r>
+              <a:t>• Branch-and-Cut Pipeline: Root cut generation (Gomory fractional / MIR) -&gt; Reliability pseudocost branching -&gt; Primal heuristics (Feasibility Pump) -&gt; Dual Simplex warm-start.</a:t>
+            </a:r>
+          </a:p>
+          <a:p>
+            <a:pPr>
+              <a:spcBef>
+                <a:spcPts val="400"/>
+              </a:spcBef>
+              <a:spcAft>
+                <a:spcPts val="200"/>
+              </a:spcAft>
+              <a:defRPr sz="1300" b="1">
+                <a:solidFill>
+                  <a:srgbClr val="005691"/>
+                </a:solidFill>
+                <a:latin typeface="Arial"/>
+              </a:defRPr>
+            </a:pPr>
+            <a:r>
+              <a:t>3. Working Prototype &amp; Verification Status</a:t>
+            </a:r>
+          </a:p>
+          <a:p>
+            <a:pPr>
+              <a:spcAft>
+                <a:spcPts val="200"/>
+              </a:spcAft>
+              <a:defRPr sz="1100" b="0">
+                <a:solidFill>
+                  <a:srgbClr val="333333"/>
+                </a:solidFill>
+                <a:latin typeface="Arial"/>
+              </a:defRPr>
+            </a:pPr>
+            <a:r>
+              <a:t>• 100% Functional Working Prototype: Solves classic Netlib benchmarks (afiro, brandy, adlittle) matching HiGHS to 10^-6–10^-16 precision.</a:t>
+            </a:r>
+          </a:p>
+          <a:p>
+            <a:pPr>
+              <a:spcAft>
+                <a:spcPts val="200"/>
+              </a:spcAft>
+              <a:defRPr sz="1100" b="0">
+                <a:solidFill>
+                  <a:srgbClr val="333333"/>
+                </a:solidFill>
+                <a:latin typeface="Arial"/>
+              </a:defRPr>
+            </a:pPr>
+            <a:r>
+              <a:t>• End-to-End Industrial Demos: Validated on Indian Crude Oil Blending (LP) and Refinery Multi-Depot Supply Chain Scheduling (MILP).</a:t>
             </a:r>
           </a:p>
         </p:txBody>
@@ -6646,10 +6991,16 @@
           <a:bodyPr rtlCol="0" anchor="ctr"/>
           <a:lstStyle/>
           <a:p>
-            <a:pPr algn="ctr"/>
-            <a:r>
-              <a:rPr lang="en-US" dirty="0"/>
-              <a:t>Your Team Name</a:t>
+            <a:pPr algn="ctr">
+              <a:defRPr sz="1100" b="1">
+                <a:solidFill>
+                  <a:srgbClr val="FFFFFF"/>
+                </a:solidFill>
+                <a:latin typeface="Arial"/>
+              </a:defRPr>
+            </a:pPr>
+            <a:r>
+              <a:t>Sovereign Solvers</a:t>
             </a:r>
             <a:endParaRPr lang="en-IN" dirty="0"/>
           </a:p>
@@ -6801,16 +7152,18 @@
         </p:nvSpPr>
         <p:spPr/>
         <p:txBody>
-          <a:bodyPr/>
+          <a:bodyPr wrap="square"/>
           <a:lstStyle/>
           <a:p>
-            <a:pPr eaLnBrk="1" hangingPunct="1"/>
-            <a:r>
-              <a:rPr lang="en-US" sz="3600" b="1" dirty="0">
-                <a:latin typeface="Times New Roman" panose="02020603050405020304" pitchFamily="18" charset="0"/>
-                <a:ea typeface="ＭＳ Ｐゴシック" pitchFamily="1" charset="-128"/>
-                <a:cs typeface="Times New Roman" panose="02020603050405020304" pitchFamily="18" charset="0"/>
-              </a:rPr>
+            <a:pPr eaLnBrk="1" hangingPunct="1">
+              <a:defRPr sz="2800" b="1">
+                <a:solidFill>
+                  <a:srgbClr val="1B365D"/>
+                </a:solidFill>
+                <a:latin typeface="Times New Roman"/>
+              </a:defRPr>
+            </a:pPr>
+            <a:r>
               <a:t>FEASIBILITY AND VIABILITY</a:t>
             </a:r>
           </a:p>
@@ -6826,8 +7179,8 @@
         </p:nvSpPr>
         <p:spPr bwMode="auto">
           <a:xfrm>
-            <a:off x="609600" y="2533653"/>
-            <a:ext cx="9385300" cy="1384995"/>
+            <a:off x="548640" y="1280160"/>
+            <a:ext cx="10972800" cy="4572000"/>
           </a:xfrm>
           <a:prstGeom prst="rect">
             <a:avLst/>
@@ -6851,27 +7204,25 @@
                 <a:spcPct val="100000"/>
               </a:lnSpc>
               <a:spcBef>
-                <a:spcPct val="0"/>
+                <a:spcPts val="400"/>
               </a:spcBef>
               <a:spcAft>
-                <a:spcPct val="0"/>
+                <a:spcPts val="200"/>
               </a:spcAft>
               <a:buClrTx/>
               <a:buSzTx/>
               <a:buFont typeface="Arial" panose="020B0604020202020204" pitchFamily="34" charset="0"/>
               <a:buChar char="•"/>
               <a:tabLst/>
-              <a:defRPr/>
-            </a:pPr>
-            <a:r>
-              <a:rPr lang="en-US" sz="2800" dirty="0">
-                <a:solidFill>
-                  <a:prstClr val="black"/>
-                </a:solidFill>
-                <a:latin typeface="Arial" pitchFamily="34" charset="0"/>
-                <a:cs typeface="Arial" pitchFamily="34" charset="0"/>
-              </a:rPr>
-              <a:t>Analysis of the feasibility of the idea</a:t>
+              <a:defRPr sz="1300" b="1">
+                <a:solidFill>
+                  <a:srgbClr val="005691"/>
+                </a:solidFill>
+                <a:latin typeface="Arial"/>
+              </a:defRPr>
+            </a:pPr>
+            <a:r>
+              <a:t>1. Analysis of Feasibility &amp; Production Viability</a:t>
             </a:r>
             <a:endParaRPr kumimoji="0" lang="en-US" sz="2800" b="0" i="0" u="none" strike="noStrike" kern="1200" cap="none" spc="0" normalizeH="0" baseline="0" noProof="0" dirty="0">
               <a:ln>
@@ -6889,100 +7240,186 @@
             </a:endParaRPr>
           </a:p>
           <a:p>
-            <a:pPr marL="342900" marR="0" lvl="0" indent="-342900" algn="just" defTabSz="457200" rtl="0" eaLnBrk="1" fontAlgn="base" latinLnBrk="0" hangingPunct="1">
-              <a:lnSpc>
-                <a:spcPct val="100000"/>
-              </a:lnSpc>
+            <a:pPr>
+              <a:spcAft>
+                <a:spcPts val="200"/>
+              </a:spcAft>
+              <a:defRPr sz="1100" b="0">
+                <a:solidFill>
+                  <a:srgbClr val="333333"/>
+                </a:solidFill>
+                <a:latin typeface="Arial"/>
+              </a:defRPr>
+            </a:pPr>
+            <a:r>
+              <a:t>• Mathematically Rigorous Foundations: Built on established numerical linear algebra and optimization theorems (Forrest-Tomlin, Mehrotra, Achterberg, Applegate).</a:t>
+            </a:r>
+          </a:p>
+          <a:p>
+            <a:pPr>
+              <a:spcAft>
+                <a:spcPts val="200"/>
+              </a:spcAft>
+              <a:defRPr sz="1100" b="0">
+                <a:solidFill>
+                  <a:srgbClr val="333333"/>
+                </a:solidFill>
+                <a:latin typeface="Arial"/>
+              </a:defRPr>
+            </a:pPr>
+            <a:r>
+              <a:t>• Zero External Solver Runtime Dependency: Pure standalone package; runs in secure, air-gapped Indian enterprise and defense environments.</a:t>
+            </a:r>
+          </a:p>
+          <a:p>
+            <a:pPr>
+              <a:spcAft>
+                <a:spcPts val="200"/>
+              </a:spcAft>
+              <a:defRPr sz="1100" b="0">
+                <a:solidFill>
+                  <a:srgbClr val="333333"/>
+                </a:solidFill>
+                <a:latin typeface="Arial"/>
+              </a:defRPr>
+            </a:pPr>
+            <a:r>
+              <a:t>• Full Format Interoperability: Direct drop-in support for standard MPS, LP, and QPS problem files with full post-solve recovery.</a:t>
+            </a:r>
+          </a:p>
+          <a:p>
+            <a:pPr>
               <a:spcBef>
-                <a:spcPct val="0"/>
+                <a:spcPts val="400"/>
               </a:spcBef>
               <a:spcAft>
-                <a:spcPct val="0"/>
+                <a:spcPts val="200"/>
               </a:spcAft>
-              <a:buClrTx/>
-              <a:buSzTx/>
-              <a:buFont typeface="Arial" panose="020B0604020202020204" pitchFamily="34" charset="0"/>
-              <a:buChar char="•"/>
-              <a:tabLst/>
-              <a:defRPr/>
-            </a:pPr>
-            <a:r>
-              <a:rPr lang="en-US" sz="2800" dirty="0">
-                <a:solidFill>
-                  <a:prstClr val="black"/>
-                </a:solidFill>
-                <a:latin typeface="Arial" pitchFamily="34" charset="0"/>
-                <a:cs typeface="Arial" pitchFamily="34" charset="0"/>
-              </a:rPr>
-              <a:t>Potential challenges and risks</a:t>
-            </a:r>
-          </a:p>
-          <a:p>
-            <a:pPr marL="342900" marR="0" lvl="0" indent="-342900" algn="just" defTabSz="457200" rtl="0" eaLnBrk="1" fontAlgn="base" latinLnBrk="0" hangingPunct="1">
-              <a:lnSpc>
-                <a:spcPct val="100000"/>
-              </a:lnSpc>
+              <a:defRPr sz="1300" b="1">
+                <a:solidFill>
+                  <a:srgbClr val="005691"/>
+                </a:solidFill>
+                <a:latin typeface="Arial"/>
+              </a:defRPr>
+            </a:pPr>
+            <a:r>
+              <a:t>2. Key Numerical Challenges &amp; Risks</a:t>
+            </a:r>
+          </a:p>
+          <a:p>
+            <a:pPr>
+              <a:spcAft>
+                <a:spcPts val="200"/>
+              </a:spcAft>
+              <a:defRPr sz="1100" b="0">
+                <a:solidFill>
+                  <a:srgbClr val="333333"/>
+                </a:solidFill>
+                <a:latin typeface="Arial"/>
+              </a:defRPr>
+            </a:pPr>
+            <a:r>
+              <a:t>• Degeneracy &amp; Stalling: Industrial models frequently encounter redundant constraints and degenerate bases that cause cycling in standard simplex.</a:t>
+            </a:r>
+          </a:p>
+          <a:p>
+            <a:pPr>
+              <a:spcAft>
+                <a:spcPts val="200"/>
+              </a:spcAft>
+              <a:defRPr sz="1100" b="0">
+                <a:solidFill>
+                  <a:srgbClr val="333333"/>
+                </a:solidFill>
+                <a:latin typeface="Arial"/>
+              </a:defRPr>
+            </a:pPr>
+            <a:r>
+              <a:t>• Combinatorial Branch-and-Bound Explosion: Unpruned search trees on difficult integer programs can grow exponentially.</a:t>
+            </a:r>
+          </a:p>
+          <a:p>
+            <a:pPr>
+              <a:spcAft>
+                <a:spcPts val="200"/>
+              </a:spcAft>
+              <a:defRPr sz="1100" b="0">
+                <a:solidFill>
+                  <a:srgbClr val="333333"/>
+                </a:solidFill>
+                <a:latin typeface="Arial"/>
+              </a:defRPr>
+            </a:pPr>
+            <a:r>
+              <a:t>• Memory Fill-in at Scale: Classical simplex LU factorization suffers from memory bottlenecks on problems exceeding 100,000 variables.</a:t>
+            </a:r>
+          </a:p>
+          <a:p>
+            <a:pPr>
               <a:spcBef>
-                <a:spcPct val="0"/>
+                <a:spcPts val="400"/>
               </a:spcBef>
               <a:spcAft>
-                <a:spcPct val="0"/>
+                <a:spcPts val="200"/>
               </a:spcAft>
-              <a:buClrTx/>
-              <a:buSzTx/>
-              <a:buFont typeface="Arial" panose="020B0604020202020204" pitchFamily="34" charset="0"/>
-              <a:buChar char="•"/>
-              <a:tabLst/>
-              <a:defRPr/>
-            </a:pPr>
-            <a:r>
-              <a:rPr kumimoji="0" lang="en-US" sz="2800" b="0" i="0" u="none" strike="noStrike" kern="1200" cap="none" spc="0" normalizeH="0" baseline="0" noProof="0" dirty="0">
-                <a:ln>
-                  <a:noFill/>
-                </a:ln>
-                <a:solidFill>
-                  <a:prstClr val="black"/>
-                </a:solidFill>
-                <a:effectLst/>
-                <a:uLnTx/>
-                <a:uFillTx/>
-                <a:latin typeface="Arial" pitchFamily="34" charset="0"/>
-                <a:ea typeface="ＭＳ Ｐゴシック" pitchFamily="1" charset="-128"/>
-                <a:cs typeface="Arial" pitchFamily="34" charset="0"/>
-              </a:rPr>
-              <a:t>Strategies</a:t>
-            </a:r>
-            <a:r>
-              <a:rPr kumimoji="0" lang="en-US" sz="2800" b="0" i="0" u="none" strike="noStrike" kern="1200" cap="none" spc="0" normalizeH="0" noProof="0" dirty="0">
-                <a:ln>
-                  <a:noFill/>
-                </a:ln>
-                <a:solidFill>
-                  <a:prstClr val="black"/>
-                </a:solidFill>
-                <a:effectLst/>
-                <a:uLnTx/>
-                <a:uFillTx/>
-                <a:latin typeface="Arial" pitchFamily="34" charset="0"/>
-                <a:ea typeface="ＭＳ Ｐゴシック" pitchFamily="1" charset="-128"/>
-                <a:cs typeface="Arial" pitchFamily="34" charset="0"/>
-              </a:rPr>
-              <a:t> for overcoming these challenges</a:t>
-            </a:r>
-            <a:endParaRPr kumimoji="0" lang="en-US" sz="2800" b="0" i="0" u="none" strike="noStrike" kern="1200" cap="none" spc="0" normalizeH="0" baseline="0" noProof="0" dirty="0">
-              <a:ln>
-                <a:noFill/>
-              </a:ln>
-              <a:solidFill>
-                <a:prstClr val="black"/>
-              </a:solidFill>
-              <a:effectLst/>
-              <a:uLnTx/>
-              <a:uFillTx/>
-              <a:latin typeface="Arial" pitchFamily="34" charset="0"/>
-              <a:ea typeface="ＭＳ Ｐゴシック" pitchFamily="1" charset="-128"/>
-              <a:cs typeface="Arial" pitchFamily="34" charset="0"/>
-            </a:endParaRPr>
+              <a:defRPr sz="1300" b="1">
+                <a:solidFill>
+                  <a:srgbClr val="005691"/>
+                </a:solidFill>
+                <a:latin typeface="Arial"/>
+              </a:defRPr>
+            </a:pPr>
+            <a:r>
+              <a:t>3. Risk Mitigation Strategies Implemented</a:t>
+            </a:r>
+          </a:p>
+          <a:p>
+            <a:pPr>
+              <a:spcAft>
+                <a:spcPts val="200"/>
+              </a:spcAft>
+              <a:defRPr sz="1100" b="0">
+                <a:solidFill>
+                  <a:srgbClr val="333333"/>
+                </a:solidFill>
+                <a:latin typeface="Arial"/>
+              </a:defRPr>
+            </a:pPr>
+            <a:r>
+              <a:t>• Degeneracy Safeguards: Harris two-pass ratio test, Devex pricing, Markowitz threshold pivoting, and dynamic basis refactorization every 50 pivots.</a:t>
+            </a:r>
+          </a:p>
+          <a:p>
+            <a:pPr>
+              <a:spcAft>
+                <a:spcPts val="200"/>
+              </a:spcAft>
+              <a:defRPr sz="1100" b="0">
+                <a:solidFill>
+                  <a:srgbClr val="333333"/>
+                </a:solidFill>
+                <a:latin typeface="Arial"/>
+              </a:defRPr>
+            </a:pPr>
+            <a:r>
+              <a:t>• Tree Pruning: Reliability pseudocost branching combined with Gomory fractional cuts prunes &gt;60% of search nodes; warm-started dual simplex accelerates re-solves.</a:t>
+            </a:r>
+          </a:p>
+          <a:p>
+            <a:pPr>
+              <a:spcAft>
+                <a:spcPts val="200"/>
+              </a:spcAft>
+              <a:defRPr sz="1100" b="0">
+                <a:solidFill>
+                  <a:srgbClr val="333333"/>
+                </a:solidFill>
+                <a:latin typeface="Arial"/>
+              </a:defRPr>
+            </a:pPr>
+            <a:r>
+              <a:t>• GPU Scalability: Pluggable GPU-resident PDHG engine replaces matrix factorizations with O(nnz) parallel SpMV, scaling to millions of variables.</a:t>
+            </a:r>
           </a:p>
         </p:txBody>
       </p:sp>
@@ -7182,10 +7619,16 @@
           <a:bodyPr rtlCol="0" anchor="ctr"/>
           <a:lstStyle/>
           <a:p>
-            <a:pPr algn="ctr"/>
-            <a:r>
-              <a:rPr lang="en-US" dirty="0"/>
-              <a:t>Your Team Name</a:t>
+            <a:pPr algn="ctr">
+              <a:defRPr sz="1100" b="1">
+                <a:solidFill>
+                  <a:srgbClr val="FFFFFF"/>
+                </a:solidFill>
+                <a:latin typeface="Arial"/>
+              </a:defRPr>
+            </a:pPr>
+            <a:r>
+              <a:t>Sovereign Solvers</a:t>
             </a:r>
             <a:endParaRPr lang="en-IN" dirty="0"/>
           </a:p>
@@ -7342,16 +7785,18 @@
         </p:nvSpPr>
         <p:spPr/>
         <p:txBody>
-          <a:bodyPr/>
+          <a:bodyPr wrap="square"/>
           <a:lstStyle/>
           <a:p>
-            <a:pPr eaLnBrk="1" hangingPunct="1"/>
-            <a:r>
-              <a:rPr lang="en-US" sz="3600" b="1" dirty="0">
-                <a:latin typeface="Times New Roman" panose="02020603050405020304" pitchFamily="18" charset="0"/>
-                <a:ea typeface="ＭＳ Ｐゴシック" pitchFamily="1" charset="-128"/>
-                <a:cs typeface="Times New Roman" panose="02020603050405020304" pitchFamily="18" charset="0"/>
-              </a:rPr>
+            <a:pPr eaLnBrk="1" hangingPunct="1">
+              <a:defRPr sz="2800" b="1">
+                <a:solidFill>
+                  <a:srgbClr val="1B365D"/>
+                </a:solidFill>
+                <a:latin typeface="Times New Roman"/>
+              </a:defRPr>
+            </a:pPr>
+            <a:r>
               <a:t>IMPACT AND BENEFITS</a:t>
             </a:r>
           </a:p>
@@ -7367,8 +7812,8 @@
         </p:nvSpPr>
         <p:spPr bwMode="auto">
           <a:xfrm>
-            <a:off x="609600" y="2533653"/>
-            <a:ext cx="9385300" cy="1384995"/>
+            <a:off x="548640" y="1280160"/>
+            <a:ext cx="10972800" cy="4572000"/>
           </a:xfrm>
           <a:prstGeom prst="rect">
             <a:avLst/>
@@ -7392,63 +7837,156 @@
                 <a:spcPct val="100000"/>
               </a:lnSpc>
               <a:spcBef>
-                <a:spcPct val="0"/>
+                <a:spcPts val="500"/>
               </a:spcBef>
               <a:spcAft>
-                <a:spcPct val="0"/>
+                <a:spcPts val="300"/>
               </a:spcAft>
               <a:buClrTx/>
               <a:buSzTx/>
               <a:buFont typeface="Arial" panose="020B0604020202020204" pitchFamily="34" charset="0"/>
               <a:buChar char="•"/>
               <a:tabLst/>
-              <a:defRPr/>
-            </a:pPr>
-            <a:r>
-              <a:rPr kumimoji="0" lang="en-US" sz="2800" b="0" i="0" u="none" strike="noStrike" kern="1200" cap="none" spc="0" normalizeH="0" baseline="0" noProof="0" dirty="0">
-                <a:ln>
-                  <a:noFill/>
-                </a:ln>
-                <a:solidFill>
-                  <a:prstClr val="black"/>
-                </a:solidFill>
-                <a:effectLst/>
-                <a:uLnTx/>
-                <a:uFillTx/>
-                <a:latin typeface="Arial" pitchFamily="34" charset="0"/>
-                <a:ea typeface="ＭＳ Ｐゴシック" pitchFamily="1" charset="-128"/>
-                <a:cs typeface="Arial" pitchFamily="34" charset="0"/>
-              </a:rPr>
-              <a:t>Potential impact on the target audience</a:t>
-            </a:r>
-          </a:p>
-          <a:p>
-            <a:pPr marL="342900" marR="0" lvl="0" indent="-342900" algn="just" defTabSz="457200" rtl="0" eaLnBrk="1" fontAlgn="base" latinLnBrk="0" hangingPunct="1">
-              <a:lnSpc>
-                <a:spcPct val="100000"/>
-              </a:lnSpc>
+              <a:defRPr sz="1300" b="1">
+                <a:solidFill>
+                  <a:srgbClr val="005691"/>
+                </a:solidFill>
+                <a:latin typeface="Arial"/>
+              </a:defRPr>
+            </a:pPr>
+            <a:r>
+              <a:t>1. Potential Impact on Target Strategic Audience</a:t>
+            </a:r>
+          </a:p>
+          <a:p>
+            <a:pPr>
+              <a:spcAft>
+                <a:spcPts val="300"/>
+              </a:spcAft>
+              <a:defRPr sz="1100" b="0">
+                <a:solidFill>
+                  <a:srgbClr val="333333"/>
+                </a:solidFill>
+                <a:latin typeface="Arial"/>
+              </a:defRPr>
+            </a:pPr>
+            <a:r>
+              <a:t>• Indian Core Industries: Provides immediate mathematical sovereignty for PSUs and private enterprises (IOCL, BPCL, ONGC, NTPC, Tata, Reliance, Indian Railways).</a:t>
+            </a:r>
+          </a:p>
+          <a:p>
+            <a:pPr>
+              <a:spcAft>
+                <a:spcPts val="300"/>
+              </a:spcAft>
+              <a:defRPr sz="1100" b="0">
+                <a:solidFill>
+                  <a:srgbClr val="333333"/>
+                </a:solidFill>
+                <a:latin typeface="Arial"/>
+              </a:defRPr>
+            </a:pPr>
+            <a:r>
+              <a:t>• National Security &amp; Self-Reliance: Immunizes critical planning, grid dispatch, and refinery operations against foreign sanctions, embargoes, or telemetry exfiltration.</a:t>
+            </a:r>
+          </a:p>
+          <a:p>
+            <a:pPr>
+              <a:spcAft>
+                <a:spcPts val="300"/>
+              </a:spcAft>
+              <a:defRPr sz="1100" b="0">
+                <a:solidFill>
+                  <a:srgbClr val="333333"/>
+                </a:solidFill>
+                <a:latin typeface="Arial"/>
+              </a:defRPr>
+            </a:pPr>
+            <a:r>
+              <a:t>• Indian Research Ecosystem: Transparent open-core solver enables DRDO, ISRO, and university researchers to study and customize solver internals.</a:t>
+            </a:r>
+          </a:p>
+          <a:p>
+            <a:pPr>
               <a:spcBef>
-                <a:spcPct val="0"/>
+                <a:spcPts val="500"/>
               </a:spcBef>
               <a:spcAft>
-                <a:spcPct val="0"/>
+                <a:spcPts val="300"/>
               </a:spcAft>
-              <a:buClrTx/>
-              <a:buSzTx/>
-              <a:buFont typeface="Arial" panose="020B0604020202020204" pitchFamily="34" charset="0"/>
-              <a:buChar char="•"/>
-              <a:tabLst/>
-              <a:defRPr/>
-            </a:pPr>
-            <a:r>
-              <a:rPr lang="en-US" sz="2800" dirty="0">
-                <a:solidFill>
-                  <a:prstClr val="black"/>
-                </a:solidFill>
-                <a:latin typeface="Arial" pitchFamily="34" charset="0"/>
-                <a:cs typeface="Arial" pitchFamily="34" charset="0"/>
-              </a:rPr>
-              <a:t>Benefits of the solution (social, economic, environmental, etc.)</a:t>
+              <a:defRPr sz="1300" b="1">
+                <a:solidFill>
+                  <a:srgbClr val="005691"/>
+                </a:solidFill>
+                <a:latin typeface="Arial"/>
+              </a:defRPr>
+            </a:pPr>
+            <a:r>
+              <a:t>2. Economic, Operational &amp; Environmental Benefits</a:t>
+            </a:r>
+          </a:p>
+          <a:p>
+            <a:pPr>
+              <a:spcAft>
+                <a:spcPts val="300"/>
+              </a:spcAft>
+              <a:defRPr sz="1100" b="0">
+                <a:solidFill>
+                  <a:srgbClr val="333333"/>
+                </a:solidFill>
+                <a:latin typeface="Arial"/>
+              </a:defRPr>
+            </a:pPr>
+            <a:r>
+              <a:t>• Massive Economic Savings (&gt; ₹100 Crore / Year): Eliminates recurring foreign software license costs ($15,000–$40,000 per engine seat per year).</a:t>
+            </a:r>
+          </a:p>
+          <a:p>
+            <a:pPr>
+              <a:spcAft>
+                <a:spcPts val="300"/>
+              </a:spcAft>
+              <a:defRPr sz="1100" b="0">
+                <a:solidFill>
+                  <a:srgbClr val="333333"/>
+                </a:solidFill>
+                <a:latin typeface="Arial"/>
+              </a:defRPr>
+            </a:pPr>
+            <a:r>
+              <a:t>• Supply Chain &amp; Refinery Optimization: Real-time schedule optimization across multi-depot distribution networks reduces transit latency and inventory holding costs.</a:t>
+            </a:r>
+          </a:p>
+          <a:p>
+            <a:pPr>
+              <a:spcAft>
+                <a:spcPts val="300"/>
+              </a:spcAft>
+              <a:defRPr sz="1100" b="0">
+                <a:solidFill>
+                  <a:srgbClr val="333333"/>
+                </a:solidFill>
+                <a:latin typeface="Arial"/>
+              </a:defRPr>
+            </a:pPr>
+            <a:r>
+              <a:t>• Environmental Sustainability: Optimized power dispatch and refinery distillation minimize fuel consumption and carbon emissions by 3%–5%.</a:t>
+            </a:r>
+          </a:p>
+          <a:p>
+            <a:pPr>
+              <a:spcAft>
+                <a:spcPts val="300"/>
+              </a:spcAft>
+              <a:defRPr sz="1100" b="0">
+                <a:solidFill>
+                  <a:srgbClr val="333333"/>
+                </a:solidFill>
+                <a:latin typeface="Arial"/>
+              </a:defRPr>
+            </a:pPr>
+            <a:r>
+              <a:t>• Atmanirbhar Bharat: Fulfills national mission goals by creating India's first homegrown sovereign optimization solver foundation.</a:t>
             </a:r>
           </a:p>
         </p:txBody>
@@ -7649,10 +8187,16 @@
           <a:bodyPr rtlCol="0" anchor="ctr"/>
           <a:lstStyle/>
           <a:p>
-            <a:pPr algn="ctr"/>
-            <a:r>
-              <a:rPr lang="en-US" dirty="0"/>
-              <a:t>Your Team Name</a:t>
+            <a:pPr algn="ctr">
+              <a:defRPr sz="1100" b="1">
+                <a:solidFill>
+                  <a:srgbClr val="FFFFFF"/>
+                </a:solidFill>
+                <a:latin typeface="Arial"/>
+              </a:defRPr>
+            </a:pPr>
+            <a:r>
+              <a:t>Sovereign Solvers</a:t>
             </a:r>
             <a:endParaRPr lang="en-IN" dirty="0"/>
           </a:p>
@@ -7809,17 +8353,19 @@
         </p:nvSpPr>
         <p:spPr/>
         <p:txBody>
-          <a:bodyPr/>
+          <a:bodyPr wrap="square"/>
           <a:lstStyle/>
           <a:p>
-            <a:pPr eaLnBrk="1" hangingPunct="1"/>
-            <a:r>
-              <a:rPr lang="en-US" sz="3600" b="1" dirty="0">
-                <a:latin typeface="Times New Roman" panose="02020603050405020304" pitchFamily="18" charset="0"/>
-                <a:ea typeface="ＭＳ Ｐゴシック" pitchFamily="1" charset="-128"/>
-                <a:cs typeface="Times New Roman" panose="02020603050405020304" pitchFamily="18" charset="0"/>
-              </a:rPr>
-              <a:t>RESEARCH  AND REFERENCES</a:t>
+            <a:pPr eaLnBrk="1" hangingPunct="1">
+              <a:defRPr sz="2800" b="1">
+                <a:solidFill>
+                  <a:srgbClr val="1B365D"/>
+                </a:solidFill>
+                <a:latin typeface="Times New Roman"/>
+              </a:defRPr>
+            </a:pPr>
+            <a:r>
+              <a:t>RESEARCH AND REFERENCES</a:t>
             </a:r>
           </a:p>
         </p:txBody>
@@ -7834,8 +8380,8 @@
         </p:nvSpPr>
         <p:spPr bwMode="auto">
           <a:xfrm>
-            <a:off x="609600" y="2795263"/>
-            <a:ext cx="9385300" cy="523220"/>
+            <a:off x="548640" y="1280160"/>
+            <a:ext cx="10972800" cy="4572000"/>
           </a:xfrm>
           <a:prstGeom prst="rect">
             <a:avLst/>
@@ -7859,27 +8405,25 @@
                 <a:spcPct val="100000"/>
               </a:lnSpc>
               <a:spcBef>
-                <a:spcPct val="0"/>
+                <a:spcPts val="400"/>
               </a:spcBef>
               <a:spcAft>
-                <a:spcPct val="0"/>
+                <a:spcPts val="200"/>
               </a:spcAft>
               <a:buClrTx/>
               <a:buSzTx/>
               <a:buFont typeface="Arial" panose="020B0604020202020204" pitchFamily="34" charset="0"/>
               <a:buChar char="•"/>
               <a:tabLst/>
-              <a:defRPr/>
-            </a:pPr>
-            <a:r>
-              <a:rPr lang="en-US" sz="2800" noProof="0" dirty="0">
-                <a:solidFill>
-                  <a:prstClr val="black"/>
-                </a:solidFill>
-                <a:latin typeface="Arial" pitchFamily="34" charset="0"/>
-                <a:cs typeface="Arial" pitchFamily="34" charset="0"/>
-              </a:rPr>
-              <a:t>Details / Links of the reference and research work</a:t>
+              <a:defRPr sz="1300" b="1">
+                <a:solidFill>
+                  <a:srgbClr val="005691"/>
+                </a:solidFill>
+                <a:latin typeface="Arial"/>
+              </a:defRPr>
+            </a:pPr>
+            <a:r>
+              <a:t>1. Foundational Mathematical &amp; Numerical Literature</a:t>
             </a:r>
             <a:endParaRPr kumimoji="0" lang="en-US" sz="2800" b="0" i="0" u="none" strike="noStrike" kern="1200" cap="none" spc="0" normalizeH="0" baseline="0" noProof="0" dirty="0">
               <a:ln>
@@ -7895,6 +8439,188 @@
               <a:ea typeface="ＭＳ Ｐゴシック" pitchFamily="1" charset="-128"/>
               <a:cs typeface="Arial" pitchFamily="34" charset="0"/>
             </a:endParaRPr>
+          </a:p>
+          <a:p>
+            <a:pPr>
+              <a:spcAft>
+                <a:spcPts val="200"/>
+              </a:spcAft>
+              <a:defRPr sz="1050" b="0">
+                <a:solidFill>
+                  <a:srgbClr val="333333"/>
+                </a:solidFill>
+                <a:latin typeface="Arial"/>
+              </a:defRPr>
+            </a:pPr>
+            <a:r>
+              <a:t>• Forrest, J.J.H., &amp; Tomlin, J.A. (1972). 'Updated Triangular Factors of the Basis to Maintain Sparsity in the Product Form Simplex Method', Mathematical Programming, 2(1), 263-278.</a:t>
+            </a:r>
+          </a:p>
+          <a:p>
+            <a:pPr>
+              <a:spcAft>
+                <a:spcPts val="200"/>
+              </a:spcAft>
+              <a:defRPr sz="1050" b="0">
+                <a:solidFill>
+                  <a:srgbClr val="333333"/>
+                </a:solidFill>
+                <a:latin typeface="Arial"/>
+              </a:defRPr>
+            </a:pPr>
+            <a:r>
+              <a:t>• Mehrotra, S. (1992). 'On the Implementation of a Primal-Dual Interior Point Method', SIAM Journal on Optimization, 2(4), 575-601.</a:t>
+            </a:r>
+          </a:p>
+          <a:p>
+            <a:pPr>
+              <a:spcAft>
+                <a:spcPts val="200"/>
+              </a:spcAft>
+              <a:defRPr sz="1050" b="0">
+                <a:solidFill>
+                  <a:srgbClr val="333333"/>
+                </a:solidFill>
+                <a:latin typeface="Arial"/>
+              </a:defRPr>
+            </a:pPr>
+            <a:r>
+              <a:t>• Achterberg, T. (2007). 'Constraint Integer Programming', Ph.D. Dissertation, Technische Universität Berlin.</a:t>
+            </a:r>
+          </a:p>
+          <a:p>
+            <a:pPr>
+              <a:spcAft>
+                <a:spcPts val="200"/>
+              </a:spcAft>
+              <a:defRPr sz="1050" b="0">
+                <a:solidFill>
+                  <a:srgbClr val="333333"/>
+                </a:solidFill>
+                <a:latin typeface="Arial"/>
+              </a:defRPr>
+            </a:pPr>
+            <a:r>
+              <a:t>• Applegate, D., Diaz, M., Hinder, O., Lu, H., Lubin, M. (2021). 'Practical Large-Scale Linear Programming using Primal-Dual Hybrid Gradient', NeurIPS 2021.</a:t>
+            </a:r>
+          </a:p>
+          <a:p>
+            <a:pPr>
+              <a:spcBef>
+                <a:spcPts val="400"/>
+              </a:spcBef>
+              <a:spcAft>
+                <a:spcPts val="200"/>
+              </a:spcAft>
+              <a:defRPr sz="1300" b="1">
+                <a:solidFill>
+                  <a:srgbClr val="005691"/>
+                </a:solidFill>
+                <a:latin typeface="Arial"/>
+              </a:defRPr>
+            </a:pPr>
+            <a:r>
+              <a:t>2. State-of-the-Art GPU Optimization Literature</a:t>
+            </a:r>
+          </a:p>
+          <a:p>
+            <a:pPr>
+              <a:spcAft>
+                <a:spcPts val="200"/>
+              </a:spcAft>
+              <a:defRPr sz="1050" b="0">
+                <a:solidFill>
+                  <a:srgbClr val="333333"/>
+                </a:solidFill>
+                <a:latin typeface="Arial"/>
+              </a:defRPr>
+            </a:pPr>
+            <a:r>
+              <a:t>• Lu, H., Yang, C., et al. (2023). 'cuPDLP.jl: A GPU Implementation of restarted PDHG for Linear Programming', arXiv:2307.11679.</a:t>
+            </a:r>
+          </a:p>
+          <a:p>
+            <a:pPr>
+              <a:spcAft>
+                <a:spcPts val="200"/>
+              </a:spcAft>
+              <a:defRPr sz="1050" b="0">
+                <a:solidFill>
+                  <a:srgbClr val="333333"/>
+                </a:solidFill>
+                <a:latin typeface="Arial"/>
+              </a:defRPr>
+            </a:pPr>
+            <a:r>
+              <a:t>• Blin, R., Gualandi, S., Lodi, A., Stellato, B. (Jan 2026). 'Batched First-Order Methods for Parallel LP Solving in MIP', arXiv:2601.21990.</a:t>
+            </a:r>
+          </a:p>
+          <a:p>
+            <a:pPr>
+              <a:spcBef>
+                <a:spcPts val="400"/>
+              </a:spcBef>
+              <a:spcAft>
+                <a:spcPts val="200"/>
+              </a:spcAft>
+              <a:defRPr sz="1300" b="1">
+                <a:solidFill>
+                  <a:srgbClr val="005691"/>
+                </a:solidFill>
+                <a:latin typeface="Arial"/>
+              </a:defRPr>
+            </a:pPr>
+            <a:r>
+              <a:t>3. Benchmark Collections &amp; Industrial Standard Specifications</a:t>
+            </a:r>
+          </a:p>
+          <a:p>
+            <a:pPr>
+              <a:spcAft>
+                <a:spcPts val="200"/>
+              </a:spcAft>
+              <a:defRPr sz="1050" b="0">
+                <a:solidFill>
+                  <a:srgbClr val="333333"/>
+                </a:solidFill>
+                <a:latin typeface="Arial"/>
+              </a:defRPr>
+            </a:pPr>
+            <a:r>
+              <a:t>• Netlib LP Test Problems: Gay, D.M. (1985), Mathematical Programming Society COAL Newsletter.</a:t>
+            </a:r>
+          </a:p>
+          <a:p>
+            <a:pPr>
+              <a:spcAft>
+                <a:spcPts val="200"/>
+              </a:spcAft>
+              <a:defRPr sz="1050" b="0">
+                <a:solidFill>
+                  <a:srgbClr val="333333"/>
+                </a:solidFill>
+                <a:latin typeface="Arial"/>
+              </a:defRPr>
+            </a:pPr>
+            <a:r>
+              <a:t>• MIPLIB 2017: Gleixner et al. (2021), 'MIPLIB 2017: Data-Driven Compilation of the 6th Mixed-Integer Programming Library', Math. Prog. Comp.</a:t>
+            </a:r>
+          </a:p>
+          <a:p>
+            <a:pPr>
+              <a:spcAft>
+                <a:spcPts val="200"/>
+              </a:spcAft>
+              <a:defRPr sz="1050" b="0">
+                <a:solidFill>
+                  <a:srgbClr val="333333"/>
+                </a:solidFill>
+                <a:latin typeface="Arial"/>
+              </a:defRPr>
+            </a:pPr>
+            <a:r>
+              <a:t>• Industry Reference Standards: Mathematical Programming System (MPS) Format Specification and CPLEX LP Format Standard.</a:t>
+            </a:r>
           </a:p>
         </p:txBody>
       </p:sp>
@@ -8094,10 +8820,16 @@
           <a:bodyPr rtlCol="0" anchor="ctr"/>
           <a:lstStyle/>
           <a:p>
-            <a:pPr algn="ctr"/>
-            <a:r>
-              <a:rPr lang="en-US" dirty="0"/>
-              <a:t>Your Team Name</a:t>
+            <a:pPr algn="ctr">
+              <a:defRPr sz="1100" b="1">
+                <a:solidFill>
+                  <a:srgbClr val="FFFFFF"/>
+                </a:solidFill>
+                <a:latin typeface="Arial"/>
+              </a:defRPr>
+            </a:pPr>
+            <a:r>
+              <a:t>Sovereign Solvers</a:t>
             </a:r>
             <a:endParaRPr lang="en-IN" dirty="0"/>
           </a:p>

</xml_diff>

<commit_message>
docs(presentation): add core mathematical formulas, algorithms, and competitive differentiation to SIH PPTX
</commit_message>
<xml_diff>
--- a/SIH2026-IDEA-Presentation-Format.pptx
+++ b/SIH2026-IDEA-Presentation-Format.pptx
@@ -5827,11 +5827,11 @@
           <a:p>
             <a:pPr>
               <a:spcAft>
-                <a:spcPts val="600"/>
+                <a:spcPts val="500"/>
               </a:spcAft>
             </a:pPr>
             <a:r>
-              <a:rPr sz="1600" b="1">
+              <a:rPr sz="1500" b="1">
                 <a:solidFill>
                   <a:srgbClr val="1B365D"/>
                 </a:solidFill>
@@ -5840,9 +5840,9 @@
               <a:t>Problem Statement ID – </a:t>
             </a:r>
             <a:r>
-              <a:rPr sz="1500" b="0">
-                <a:solidFill>
-                  <a:srgbClr val="333333"/>
+              <a:rPr sz="1400" b="0">
+                <a:solidFill>
+                  <a:srgbClr val="222222"/>
                 </a:solidFill>
                 <a:latin typeface="Arial"/>
               </a:rPr>
@@ -5853,11 +5853,11 @@
           <a:p>
             <a:pPr>
               <a:spcAft>
-                <a:spcPts val="600"/>
+                <a:spcPts val="500"/>
               </a:spcAft>
             </a:pPr>
             <a:r>
-              <a:rPr sz="1600" b="1">
+              <a:rPr sz="1500" b="1">
                 <a:solidFill>
                   <a:srgbClr val="1B365D"/>
                 </a:solidFill>
@@ -5866,9 +5866,9 @@
               <a:t>Problem Statement Title – </a:t>
             </a:r>
             <a:r>
-              <a:rPr sz="1500" b="0">
-                <a:solidFill>
-                  <a:srgbClr val="333333"/>
+              <a:rPr sz="1400" b="0">
+                <a:solidFill>
+                  <a:srgbClr val="222222"/>
                 </a:solidFill>
                 <a:latin typeface="Arial"/>
               </a:rPr>
@@ -5878,11 +5878,11 @@
           <a:p>
             <a:pPr>
               <a:spcAft>
-                <a:spcPts val="600"/>
+                <a:spcPts val="500"/>
               </a:spcAft>
             </a:pPr>
             <a:r>
-              <a:rPr sz="1600" b="1">
+              <a:rPr sz="1500" b="1">
                 <a:solidFill>
                   <a:srgbClr val="1B365D"/>
                 </a:solidFill>
@@ -5891,23 +5891,23 @@
               <a:t>Theme – </a:t>
             </a:r>
             <a:r>
-              <a:rPr sz="1500" b="0">
-                <a:solidFill>
-                  <a:srgbClr val="333333"/>
+              <a:rPr sz="1400" b="0">
+                <a:solidFill>
+                  <a:srgbClr val="222222"/>
                 </a:solidFill>
                 <a:latin typeface="Arial"/>
               </a:rPr>
-              <a:t>Strategic Infrastructure &amp; Computational Systems</a:t>
+              <a:t>Strategic Infrastructure &amp; Computational Mathematics</a:t>
             </a:r>
           </a:p>
           <a:p>
             <a:pPr>
               <a:spcAft>
-                <a:spcPts val="600"/>
+                <a:spcPts val="500"/>
               </a:spcAft>
             </a:pPr>
             <a:r>
-              <a:rPr sz="1600" b="1">
+              <a:rPr sz="1500" b="1">
                 <a:solidFill>
                   <a:srgbClr val="1B365D"/>
                 </a:solidFill>
@@ -5916,9 +5916,9 @@
               <a:t>PS Category – </a:t>
             </a:r>
             <a:r>
-              <a:rPr sz="1500" b="0">
-                <a:solidFill>
-                  <a:srgbClr val="333333"/>
+              <a:rPr sz="1400" b="0">
+                <a:solidFill>
+                  <a:srgbClr val="222222"/>
                 </a:solidFill>
                 <a:latin typeface="Arial"/>
               </a:rPr>
@@ -5928,11 +5928,11 @@
           <a:p>
             <a:pPr>
               <a:spcAft>
-                <a:spcPts val="600"/>
+                <a:spcPts val="500"/>
               </a:spcAft>
             </a:pPr>
             <a:r>
-              <a:rPr sz="1600" b="1">
+              <a:rPr sz="1500" b="1">
                 <a:solidFill>
                   <a:srgbClr val="1B365D"/>
                 </a:solidFill>
@@ -5941,9 +5941,9 @@
               <a:t>Team ID – </a:t>
             </a:r>
             <a:r>
-              <a:rPr sz="1500" b="0">
-                <a:solidFill>
-                  <a:srgbClr val="333333"/>
+              <a:rPr sz="1400" b="0">
+                <a:solidFill>
+                  <a:srgbClr val="222222"/>
                 </a:solidFill>
                 <a:latin typeface="Arial"/>
               </a:rPr>
@@ -5953,11 +5953,11 @@
           <a:p>
             <a:pPr>
               <a:spcAft>
-                <a:spcPts val="600"/>
+                <a:spcPts val="500"/>
               </a:spcAft>
             </a:pPr>
             <a:r>
-              <a:rPr sz="1600" b="1">
+              <a:rPr sz="1500" b="1">
                 <a:solidFill>
                   <a:srgbClr val="1B365D"/>
                 </a:solidFill>
@@ -5966,9 +5966,9 @@
               <a:t>Team Name – </a:t>
             </a:r>
             <a:r>
-              <a:rPr sz="1500" b="0">
-                <a:solidFill>
-                  <a:srgbClr val="333333"/>
+              <a:rPr sz="1400" b="0">
+                <a:solidFill>
+                  <a:srgbClr val="222222"/>
                 </a:solidFill>
                 <a:latin typeface="Arial"/>
               </a:rPr>
@@ -6111,7 +6111,7 @@
           <a:lstStyle/>
           <a:p>
             <a:pPr eaLnBrk="1" hangingPunct="1">
-              <a:defRPr sz="2800" b="1">
+              <a:defRPr sz="2600" b="1">
                 <a:solidFill>
                   <a:srgbClr val="1B365D"/>
                 </a:solidFill>
@@ -6119,7 +6119,7 @@
               </a:defRPr>
             </a:pPr>
             <a:r>
-              <a:t>SOVEREIGN OPTIMIZATION SOLVER CORE</a:t>
+              <a:t>PROPOSED SOLUTION &amp; COMPETITIVE DIFFERENTIATION</a:t>
             </a:r>
           </a:p>
         </p:txBody>
@@ -6134,8 +6134,8 @@
         </p:nvSpPr>
         <p:spPr bwMode="auto">
           <a:xfrm>
-            <a:off x="548640" y="1280160"/>
-            <a:ext cx="10972800" cy="4572000"/>
+            <a:off x="548640" y="1234440"/>
+            <a:ext cx="10972800" cy="4663440"/>
           </a:xfrm>
           <a:prstGeom prst="rect">
             <a:avLst/>
@@ -6156,14 +6156,14 @@
           <a:p>
             <a:pPr marL="342900" indent="-342900">
               <a:spcBef>
-                <a:spcPts val="400"/>
+                <a:spcPts val="300"/>
               </a:spcBef>
               <a:spcAft>
-                <a:spcPts val="200"/>
+                <a:spcPts val="100"/>
               </a:spcAft>
               <a:buFont typeface="Wingdings" panose="05000000000000000000" pitchFamily="2" charset="2"/>
               <a:buChar char="v"/>
-              <a:defRPr sz="1300" b="1">
+              <a:defRPr sz="1250" b="1">
                 <a:solidFill>
                   <a:srgbClr val="005691"/>
                 </a:solidFill>
@@ -6171,7 +6171,7 @@
               </a:defRPr>
             </a:pPr>
             <a:r>
-              <a:t>1. Proposed Solution (Idea / Prototype Overview)</a:t>
+              <a:t>1. Proposed Solution — 100% From-Scratch Sovereign Core</a:t>
             </a:r>
             <a:endParaRPr lang="en-US" sz="3200" u="sng" dirty="0">
               <a:solidFill>
@@ -6186,15 +6186,15 @@
               <a:spcAft>
                 <a:spcPts val="200"/>
               </a:spcAft>
-              <a:defRPr sz="1100" b="0">
-                <a:solidFill>
-                  <a:srgbClr val="333333"/>
+              <a:defRPr sz="1000" b="0">
+                <a:solidFill>
+                  <a:srgbClr val="222222"/>
                 </a:solidFill>
                 <a:latin typeface="Arial"/>
               </a:defRPr>
             </a:pPr>
             <a:r>
-              <a:t>• Built an industrial-grade Sovereign Mathematical Optimization Engine from scratch in Python/NumPy/SciPy without wrapping any foreign commercial (Gurobi, CPLEX) or open-source solvers (HiGHS, SCIP, CBC).</a:t>
+              <a:t>• Built an industrial mathematical optimization engine from pure mathematical foundation in Python/NumPy/SciPy — zero wrapper or binary dependencies on foreign or open-source solver libraries.</a:t>
             </a:r>
           </a:p>
           <a:p>
@@ -6202,26 +6202,26 @@
               <a:spcAft>
                 <a:spcPts val="200"/>
               </a:spcAft>
-              <a:defRPr sz="1100" b="0">
-                <a:solidFill>
-                  <a:srgbClr val="333333"/>
+              <a:defRPr sz="1000" b="0">
+                <a:solidFill>
+                  <a:srgbClr val="222222"/>
                 </a:solidFill>
                 <a:latin typeface="Arial"/>
               </a:defRPr>
             </a:pPr>
             <a:r>
-              <a:t>• Delivers complete solver capabilities for Linear Programming (LP), Mixed-Integer LP (MILP), and Quadratic Programming (QP) with native MPS, LP, and QPS format readers.</a:t>
+              <a:t>• Complete Algorithmic Spectrum: Linear Programming (LP), Mixed-Integer Linear Programming (MILP), and Quadratic Programming (QP) with standard MPS, LP, and QPS format readers.</a:t>
             </a:r>
           </a:p>
           <a:p>
             <a:pPr>
               <a:spcBef>
-                <a:spcPts val="400"/>
+                <a:spcPts val="300"/>
               </a:spcBef>
               <a:spcAft>
-                <a:spcPts val="200"/>
+                <a:spcPts val="100"/>
               </a:spcAft>
-              <a:defRPr sz="1300" b="1">
+              <a:defRPr sz="1250" b="1">
                 <a:solidFill>
                   <a:srgbClr val="005691"/>
                 </a:solidFill>
@@ -6229,7 +6229,7 @@
               </a:defRPr>
             </a:pPr>
             <a:r>
-              <a:t>2. Detailed Explanation of the Proposed Solution</a:t>
+              <a:t>2. How We Differ from Existing Solutions (The Key Differentiators)</a:t>
             </a:r>
           </a:p>
           <a:p>
@@ -6237,15 +6237,15 @@
               <a:spcAft>
                 <a:spcPts val="200"/>
               </a:spcAft>
-              <a:defRPr sz="1100" b="0">
-                <a:solidFill>
-                  <a:srgbClr val="333333"/>
+              <a:defRPr sz="1000" b="0">
+                <a:solidFill>
+                  <a:srgbClr val="222222"/>
                 </a:solidFill>
                 <a:latin typeface="Arial"/>
               </a:defRPr>
             </a:pPr>
             <a:r>
-              <a:t>• Continuous LP Core: Sparse Revised Simplex with Forrest-Tomlin dynamic LU updates + Mehrotra Predictor-Corrector Interior Point Method (IPM) with basis crossover + Restarted PDHG.</a:t>
+              <a:t>• vs. Foreign Commercial Engines (Gurobi, CPLEX, FICO Xpress): Eliminates $15,000–$40,000/seat/year recurring foreign licensing fees; removes black-box risk with 100% auditable algorithms; insulates India's critical infrastructure (refineries, power grids) from foreign software embargoes and telemetry leaks.</a:t>
             </a:r>
           </a:p>
           <a:p>
@@ -6253,15 +6253,34 @@
               <a:spcAft>
                 <a:spcPts val="200"/>
               </a:spcAft>
-              <a:defRPr sz="1100" b="0">
-                <a:solidFill>
-                  <a:srgbClr val="333333"/>
+              <a:defRPr sz="1000" b="0">
+                <a:solidFill>
+                  <a:srgbClr val="222222"/>
                 </a:solidFill>
                 <a:latin typeface="Arial"/>
               </a:defRPr>
             </a:pPr>
             <a:r>
-              <a:t>• Mixed-Integer LP Core: Branch-and-Cut with Chvátal-Gomory, MIR, and clique cuts; reliability pseudocost branching; primal heuristics (Feasibility Pump, RINS, diving); and warm-started dual simplex.</a:t>
+              <a:t>• vs. Legacy Open-Source Engines (HiGHS, SCIP, CBC, GLPK): Built as a modern, clean, extensible architecture rather than legacy C/C++ monolithic codebases; introduces native GPU-resident LP acceleration (cuPDLP-style restarted PDHG) which existing open-source solvers lack; directly incorporates Indian PSU industrial models (IOCL/BPCL crude blending &amp; railway multi-depot supply chains).</a:t>
+            </a:r>
+          </a:p>
+          <a:p>
+            <a:pPr>
+              <a:spcBef>
+                <a:spcPts val="300"/>
+              </a:spcBef>
+              <a:spcAft>
+                <a:spcPts val="100"/>
+              </a:spcAft>
+              <a:defRPr sz="1250" b="1">
+                <a:solidFill>
+                  <a:srgbClr val="005691"/>
+                </a:solidFill>
+                <a:latin typeface="Arial"/>
+              </a:defRPr>
+            </a:pPr>
+            <a:r>
+              <a:t>3. Architectural Uniqueness &amp; Innovation</a:t>
             </a:r>
           </a:p>
           <a:p>
@@ -6269,34 +6288,15 @@
               <a:spcAft>
                 <a:spcPts val="200"/>
               </a:spcAft>
-              <a:defRPr sz="1100" b="0">
-                <a:solidFill>
-                  <a:srgbClr val="333333"/>
+              <a:defRPr sz="1000" b="0">
+                <a:solidFill>
+                  <a:srgbClr val="222222"/>
                 </a:solidFill>
                 <a:latin typeface="Arial"/>
               </a:defRPr>
             </a:pPr>
             <a:r>
-              <a:t>• Quadratic Programming (QP): Alternating Direction Method of Multipliers (ADMM) with active-set solution polishing.</a:t>
-            </a:r>
-          </a:p>
-          <a:p>
-            <a:pPr>
-              <a:spcBef>
-                <a:spcPts val="400"/>
-              </a:spcBef>
-              <a:spcAft>
-                <a:spcPts val="200"/>
-              </a:spcAft>
-              <a:defRPr sz="1300" b="1">
-                <a:solidFill>
-                  <a:srgbClr val="005691"/>
-                </a:solidFill>
-                <a:latin typeface="Arial"/>
-              </a:defRPr>
-            </a:pPr>
-            <a:r>
-              <a:t>3. How It Addresses the Problem &amp; National Need</a:t>
+              <a:t>• Dual-Engine Flexibility: Dispatches to Sparse Revised Simplex for tight extreme-point solutions, Mehrotra IPM for massive interior solutions, or GPU PDHG for high-throughput first-order solves.</a:t>
             </a:r>
           </a:p>
           <a:p>
@@ -6304,82 +6304,15 @@
               <a:spcAft>
                 <a:spcPts val="200"/>
               </a:spcAft>
-              <a:defRPr sz="1100" b="0">
-                <a:solidFill>
-                  <a:srgbClr val="333333"/>
+              <a:defRPr sz="1000" b="0">
+                <a:solidFill>
+                  <a:srgbClr val="222222"/>
                 </a:solidFill>
                 <a:latin typeface="Arial"/>
               </a:defRPr>
             </a:pPr>
             <a:r>
-              <a:t>• Breaks critical dependence on expensive foreign licenses across India's refining, power dispatch, logistics, and planning sectors.</a:t>
-            </a:r>
-          </a:p>
-          <a:p>
-            <a:pPr>
-              <a:spcAft>
-                <a:spcPts val="200"/>
-              </a:spcAft>
-              <a:defRPr sz="1100" b="0">
-                <a:solidFill>
-                  <a:srgbClr val="333333"/>
-                </a:solidFill>
-                <a:latin typeface="Arial"/>
-              </a:defRPr>
-            </a:pPr>
-            <a:r>
-              <a:t>• Provides complete mathematical transparency, preventing proprietary vendor lock-in and geopolitical software embargoes on national infrastructure.</a:t>
-            </a:r>
-          </a:p>
-          <a:p>
-            <a:pPr>
-              <a:spcBef>
-                <a:spcPts val="400"/>
-              </a:spcBef>
-              <a:spcAft>
-                <a:spcPts val="200"/>
-              </a:spcAft>
-              <a:defRPr sz="1300" b="1">
-                <a:solidFill>
-                  <a:srgbClr val="005691"/>
-                </a:solidFill>
-                <a:latin typeface="Arial"/>
-              </a:defRPr>
-            </a:pPr>
-            <a:r>
-              <a:t>4. Innovation &amp; Uniqueness of the Solution</a:t>
-            </a:r>
-          </a:p>
-          <a:p>
-            <a:pPr>
-              <a:spcAft>
-                <a:spcPts val="200"/>
-              </a:spcAft>
-              <a:defRPr sz="1100" b="0">
-                <a:solidFill>
-                  <a:srgbClr val="333333"/>
-                </a:solidFill>
-                <a:latin typeface="Arial"/>
-              </a:defRPr>
-            </a:pPr>
-            <a:r>
-              <a:t>• First Sovereign GPU-Resident LP Engine (pdhg_gpu): Accelerates restarted PDHG using CuPy/CUDA and Apple Metal (MPS), unlocking 3x–7x speedup on massive industrial models (&gt;100k variables).</a:t>
-            </a:r>
-          </a:p>
-          <a:p>
-            <a:pPr>
-              <a:spcAft>
-                <a:spcPts val="200"/>
-              </a:spcAft>
-              <a:defRPr sz="1100" b="0">
-                <a:solidFill>
-                  <a:srgbClr val="333333"/>
-                </a:solidFill>
-                <a:latin typeface="Arial"/>
-              </a:defRPr>
-            </a:pPr>
-            <a:r>
-              <a:t>• High Numerical Robustness: Integrated Ruiz equilibration scaling, Harris two-pass ratio test, and Bland anti-cycling safeguards.</a:t>
+              <a:t>• Full Mathematical Transparency: Indian defense (DRDO), space (ISRO), and energy sectors can inspect, modify, and harden solver internals to suit strategic national requirements.</a:t>
             </a:r>
           </a:p>
         </p:txBody>
@@ -6647,7 +6580,7 @@
           <a:lstStyle/>
           <a:p>
             <a:pPr eaLnBrk="1" hangingPunct="1">
-              <a:defRPr sz="2800" b="1">
+              <a:defRPr sz="2600" b="1">
                 <a:solidFill>
                   <a:srgbClr val="1B365D"/>
                 </a:solidFill>
@@ -6655,7 +6588,7 @@
               </a:defRPr>
             </a:pPr>
             <a:r>
-              <a:t>TECHNICAL APPROACH &amp; METHODOLOGY</a:t>
+              <a:t>TECHNICAL APPROACH — CORE ALGORITHMS &amp; MATHEMATICS</a:t>
             </a:r>
           </a:p>
         </p:txBody>
@@ -6670,8 +6603,8 @@
         </p:nvSpPr>
         <p:spPr bwMode="auto">
           <a:xfrm>
-            <a:off x="548640" y="1280160"/>
-            <a:ext cx="10972800" cy="4572000"/>
+            <a:off x="548640" y="1234440"/>
+            <a:ext cx="10972800" cy="4663440"/>
           </a:xfrm>
           <a:prstGeom prst="rect">
             <a:avLst/>
@@ -6692,14 +6625,14 @@
           <a:p>
             <a:pPr marL="342900" indent="-342900" algn="just">
               <a:spcBef>
-                <a:spcPts val="400"/>
+                <a:spcPts val="300"/>
               </a:spcBef>
               <a:spcAft>
-                <a:spcPts val="200"/>
+                <a:spcPts val="100"/>
               </a:spcAft>
               <a:buFont typeface="Arial" panose="020B0604020202020204" pitchFamily="34" charset="0"/>
               <a:buChar char="•"/>
-              <a:defRPr sz="1300" b="1">
+              <a:defRPr sz="1150" b="1">
                 <a:solidFill>
                   <a:srgbClr val="005691"/>
                 </a:solidFill>
@@ -6707,7 +6640,7 @@
               </a:defRPr>
             </a:pPr>
             <a:r>
-              <a:t>1. Technologies &amp; Computational Stack</a:t>
+              <a:t>1. Continuous LP Core — Dynamic LU Updates, Mehrotra IPM &amp; GPU PDHG</a:t>
             </a:r>
           </a:p>
           <a:p>
@@ -6715,15 +6648,15 @@
               <a:spcAft>
                 <a:spcPts val="200"/>
               </a:spcAft>
-              <a:defRPr sz="1100" b="0">
-                <a:solidFill>
-                  <a:srgbClr val="333333"/>
+              <a:defRPr sz="950" b="0">
+                <a:solidFill>
+                  <a:srgbClr val="222222"/>
                 </a:solidFill>
                 <a:latin typeface="Arial"/>
               </a:defRPr>
             </a:pPr>
             <a:r>
-              <a:t>• Core Engine: Python 3.14, NumPy 2.x (SIMD vectorization), SciPy (sparse CSR/CSC algebra, sparse LU factorization, COLAMD/AMD ordering).</a:t>
+              <a:t>• Forrest-Tomlin Revised Simplex: Solves min cᵀx s.t. Ax=b, x≥0. Maintains basis factorization B = L·U. When column a_q enters and column p leaves, basis updates as B_{k+1} = B_k + (a_q - B_k e_p)e_pᵀ. Solved via Product Form of Inverse (PFI) E_k·B_k⁻¹ with Harris two-pass ratio test, avoiding costly full LU re-factorizations for 50 pivots.</a:t>
             </a:r>
           </a:p>
           <a:p>
@@ -6731,15 +6664,15 @@
               <a:spcAft>
                 <a:spcPts val="200"/>
               </a:spcAft>
-              <a:defRPr sz="1100" b="0">
-                <a:solidFill>
-                  <a:srgbClr val="333333"/>
+              <a:defRPr sz="950" b="0">
+                <a:solidFill>
+                  <a:srgbClr val="222222"/>
                 </a:solidFill>
                 <a:latin typeface="Arial"/>
               </a:defRPr>
             </a:pPr>
             <a:r>
-              <a:t>• GPU Acceleration: CuPy (CUDA) &amp; PyTorch (CUDA / Apple Metal MPS) for memory-resident sparse matrix-vector products (SpMV).</a:t>
+              <a:t>• Mehrotra Primal-Dual IPM: Solves nonlinear KKT system [0 Aᵀ I; A 0 0; S 0 X] [Δx; Δy; Δs] = [r_c; r_b; -XSe + σμε]. Employs affine-scaling predictor, adaptive centering parameter σ = (μ_aff / μ)³, Mehrotra corrector step, dynamic diagonal regularization λ ~ μ, and basis crossover.</a:t>
             </a:r>
           </a:p>
           <a:p>
@@ -6747,26 +6680,26 @@
               <a:spcAft>
                 <a:spcPts val="200"/>
               </a:spcAft>
-              <a:defRPr sz="1100" b="0">
-                <a:solidFill>
-                  <a:srgbClr val="333333"/>
+              <a:defRPr sz="950" b="0">
+                <a:solidFill>
+                  <a:srgbClr val="222222"/>
                 </a:solidFill>
                 <a:latin typeface="Arial"/>
               </a:defRPr>
             </a:pPr>
             <a:r>
-              <a:t>• Validation Harness: PyTest test suite (198 passed automated tests), Netlib LP suite, MIPLIB 2017 library, and HiGHS dual-reference cross-checks.</a:t>
+              <a:t>• Restarted PDHG on GPU (PDLP): Saddle-point L(x,y) = cᵀx + yᵀ(b - Ax). Primal update: x_{k+1} = max(0, x_k - τ(c - Aᵀy_k)); Extrapolation: x̄ = 2x_{k+1} - x_k; Dual update: y_{k+1} = y_k + σ(b - Ax̄). Step sizes τ_j = 0.999/Σ_i|A_ij|, σ_i = 0.999/Σ_j|A_ij|. Adaptive restart triggers upon 50% relative KKT error reduction.</a:t>
             </a:r>
           </a:p>
           <a:p>
             <a:pPr>
               <a:spcBef>
-                <a:spcPts val="400"/>
+                <a:spcPts val="300"/>
               </a:spcBef>
               <a:spcAft>
-                <a:spcPts val="200"/>
+                <a:spcPts val="100"/>
               </a:spcAft>
-              <a:defRPr sz="1300" b="1">
+              <a:defRPr sz="1150" b="1">
                 <a:solidFill>
                   <a:srgbClr val="005691"/>
                 </a:solidFill>
@@ -6774,7 +6707,7 @@
               </a:defRPr>
             </a:pPr>
             <a:r>
-              <a:t>2. Algorithmic Pipeline &amp; Architecture</a:t>
+              <a:t>2. Discrete MILP Core — Branch-and-Cut, Cutting Planes &amp; Branching</a:t>
             </a:r>
           </a:p>
           <a:p>
@@ -6782,15 +6715,15 @@
               <a:spcAft>
                 <a:spcPts val="200"/>
               </a:spcAft>
-              <a:defRPr sz="1100" b="0">
-                <a:solidFill>
-                  <a:srgbClr val="333333"/>
+              <a:defRPr sz="950" b="0">
+                <a:solidFill>
+                  <a:srgbClr val="222222"/>
                 </a:solidFill>
                 <a:latin typeface="Arial"/>
               </a:defRPr>
             </a:pPr>
             <a:r>
-              <a:t>• Multi-Pass Presolve: Implied bound tightening, singleton row substitution, dual fixing, and coefficient strengthening reducing model size by 20%–60%.</a:t>
+              <a:t>• Chvátal-Gomory Fractional Cuts: From optimal simplex tableau row x_i + Σ_{j∈N} ā_ij x_j = b̄_i, derives valid inequality Σ_{j∈N} (ā_ij - ⌊ā_ij⌋) x_j ≥ (b̄_i - ⌊b̄_i⌋). Cuts off fractional vertex without excluding any integer feasible points.</a:t>
             </a:r>
           </a:p>
           <a:p>
@@ -6798,15 +6731,15 @@
               <a:spcAft>
                 <a:spcPts val="200"/>
               </a:spcAft>
-              <a:defRPr sz="1100" b="0">
-                <a:solidFill>
-                  <a:srgbClr val="333333"/>
+              <a:defRPr sz="950" b="0">
+                <a:solidFill>
+                  <a:srgbClr val="222222"/>
                 </a:solidFill>
                 <a:latin typeface="Arial"/>
               </a:defRPr>
             </a:pPr>
             <a:r>
-              <a:t>• Scaling &amp; Conditioning: Ruiz equilibration row/column normalization mitigating ill-conditioned matrices (condition number &gt; 10^8).</a:t>
+              <a:t>• Reliability Pseudocost Branching: Estimates objective degradation Δz_j⁻ = q_j⁻ · f_j, Δz_j⁺ = q_j⁺ · (1 - f_j). Evaluates score_j = (1 - μ) min(q_j⁻, q_j⁺) + μ max(q_j⁻, q_j⁺) (μ = 0.16). Uninitialized variables evaluated via lookahead strong branching until reliability threshold η = 8.</a:t>
             </a:r>
           </a:p>
           <a:p>
@@ -6814,26 +6747,26 @@
               <a:spcAft>
                 <a:spcPts val="200"/>
               </a:spcAft>
-              <a:defRPr sz="1100" b="0">
-                <a:solidFill>
-                  <a:srgbClr val="333333"/>
+              <a:defRPr sz="950" b="0">
+                <a:solidFill>
+                  <a:srgbClr val="222222"/>
                 </a:solidFill>
                 <a:latin typeface="Arial"/>
               </a:defRPr>
             </a:pPr>
             <a:r>
-              <a:t>• Branch-and-Cut Pipeline: Root cut generation (Gomory fractional / MIR) -&gt; Reliability pseudocost branching -&gt; Primal heuristics (Feasibility Pump) -&gt; Dual Simplex warm-start.</a:t>
+              <a:t>• Primal Heuristics: Feasibility Pump minimizes ||x - z||₁ alternating between LP projection and integer rounding; RINS fixes variables matching current incumbent and LP relaxation.</a:t>
             </a:r>
           </a:p>
           <a:p>
             <a:pPr>
               <a:spcBef>
-                <a:spcPts val="400"/>
+                <a:spcPts val="300"/>
               </a:spcBef>
               <a:spcAft>
-                <a:spcPts val="200"/>
+                <a:spcPts val="100"/>
               </a:spcAft>
-              <a:defRPr sz="1300" b="1">
+              <a:defRPr sz="1150" b="1">
                 <a:solidFill>
                   <a:srgbClr val="005691"/>
                 </a:solidFill>
@@ -6841,7 +6774,7 @@
               </a:defRPr>
             </a:pPr>
             <a:r>
-              <a:t>3. Working Prototype &amp; Verification Status</a:t>
+              <a:t>3. Presolve &amp; Scaling — Numerical Conditioning</a:t>
             </a:r>
           </a:p>
           <a:p>
@@ -6849,15 +6782,15 @@
               <a:spcAft>
                 <a:spcPts val="200"/>
               </a:spcAft>
-              <a:defRPr sz="1100" b="0">
-                <a:solidFill>
-                  <a:srgbClr val="333333"/>
+              <a:defRPr sz="950" b="0">
+                <a:solidFill>
+                  <a:srgbClr val="222222"/>
                 </a:solidFill>
                 <a:latin typeface="Arial"/>
               </a:defRPr>
             </a:pPr>
             <a:r>
-              <a:t>• 100% Functional Working Prototype: Solves classic Netlib benchmarks (afiro, brandy, adlittle) matching HiGHS to 10^-6–10^-16 precision.</a:t>
+              <a:t>• Ruiz Equilibration: Iterative scaling D_r A D_c such that lim_{k→∞} ||A_{i,:}||_∞ = 1, ||A_{:,j}||_∞ = 1, preventing numerical breakdown on ill-conditioned systems (κ(A) &gt; 10⁸).</a:t>
             </a:r>
           </a:p>
           <a:p>
@@ -6865,15 +6798,15 @@
               <a:spcAft>
                 <a:spcPts val="200"/>
               </a:spcAft>
-              <a:defRPr sz="1100" b="0">
-                <a:solidFill>
-                  <a:srgbClr val="333333"/>
+              <a:defRPr sz="950" b="0">
+                <a:solidFill>
+                  <a:srgbClr val="222222"/>
                 </a:solidFill>
                 <a:latin typeface="Arial"/>
               </a:defRPr>
             </a:pPr>
             <a:r>
-              <a:t>• End-to-End Industrial Demos: Validated on Indian Crude Oil Blending (LP) and Refinery Multi-Depot Supply Chain Scheduling (MILP).</a:t>
+              <a:t>• Presolve Reductions: 7-step multi-pass reduction (implied bound tightening, singleton row substitution, dominated column removal, dual fixing, and coefficient strengthening).</a:t>
             </a:r>
           </a:p>
         </p:txBody>
@@ -7156,7 +7089,7 @@
           <a:lstStyle/>
           <a:p>
             <a:pPr eaLnBrk="1" hangingPunct="1">
-              <a:defRPr sz="2800" b="1">
+              <a:defRPr sz="2600" b="1">
                 <a:solidFill>
                   <a:srgbClr val="1B365D"/>
                 </a:solidFill>
@@ -7164,7 +7097,7 @@
               </a:defRPr>
             </a:pPr>
             <a:r>
-              <a:t>FEASIBILITY AND VIABILITY</a:t>
+              <a:t>FEASIBILITY, VIABILITY &amp; NUMERICAL SAFEGUARDS</a:t>
             </a:r>
           </a:p>
         </p:txBody>
@@ -7179,8 +7112,8 @@
         </p:nvSpPr>
         <p:spPr bwMode="auto">
           <a:xfrm>
-            <a:off x="548640" y="1280160"/>
-            <a:ext cx="10972800" cy="4572000"/>
+            <a:off x="548640" y="1234440"/>
+            <a:ext cx="10972800" cy="4663440"/>
           </a:xfrm>
           <a:prstGeom prst="rect">
             <a:avLst/>
@@ -7204,17 +7137,17 @@
                 <a:spcPct val="100000"/>
               </a:lnSpc>
               <a:spcBef>
-                <a:spcPts val="400"/>
+                <a:spcPts val="300"/>
               </a:spcBef>
               <a:spcAft>
-                <a:spcPts val="200"/>
+                <a:spcPts val="100"/>
               </a:spcAft>
               <a:buClrTx/>
               <a:buSzTx/>
               <a:buFont typeface="Arial" panose="020B0604020202020204" pitchFamily="34" charset="0"/>
               <a:buChar char="•"/>
               <a:tabLst/>
-              <a:defRPr sz="1300" b="1">
+              <a:defRPr sz="1200" b="1">
                 <a:solidFill>
                   <a:srgbClr val="005691"/>
                 </a:solidFill>
@@ -7222,7 +7155,7 @@
               </a:defRPr>
             </a:pPr>
             <a:r>
-              <a:t>1. Analysis of Feasibility &amp; Production Viability</a:t>
+              <a:t>1. Mathematical Feasibility &amp; Numerical Stability Safeguards</a:t>
             </a:r>
             <a:endParaRPr kumimoji="0" lang="en-US" sz="2800" b="0" i="0" u="none" strike="noStrike" kern="1200" cap="none" spc="0" normalizeH="0" baseline="0" noProof="0" dirty="0">
               <a:ln>
@@ -7244,15 +7177,15 @@
               <a:spcAft>
                 <a:spcPts val="200"/>
               </a:spcAft>
-              <a:defRPr sz="1100" b="0">
-                <a:solidFill>
-                  <a:srgbClr val="333333"/>
+              <a:defRPr sz="1000" b="0">
+                <a:solidFill>
+                  <a:srgbClr val="222222"/>
                 </a:solidFill>
                 <a:latin typeface="Arial"/>
               </a:defRPr>
             </a:pPr>
             <a:r>
-              <a:t>• Mathematically Rigorous Foundations: Built on established numerical linear algebra and optimization theorems (Forrest-Tomlin, Mehrotra, Achterberg, Applegate).</a:t>
+              <a:t>• Harris Two-Pass Ratio Test: Replaces textbook ratio test with dynamic tolerance δ = 10⁻⁶: Pass 1 finds maximum step θ_max = min_i {(x_Bi - l_i + δ) / d_i : d_i &gt; 0}; Pass 2 selects pivot with largest pivot element |d_i| among candidates satisfying step ≤ θ_max, completely suppressing cycling and stalling on degenerate industrial models.</a:t>
             </a:r>
           </a:p>
           <a:p>
@@ -7260,15 +7193,15 @@
               <a:spcAft>
                 <a:spcPts val="200"/>
               </a:spcAft>
-              <a:defRPr sz="1100" b="0">
-                <a:solidFill>
-                  <a:srgbClr val="333333"/>
+              <a:defRPr sz="1000" b="0">
+                <a:solidFill>
+                  <a:srgbClr val="222222"/>
                 </a:solidFill>
                 <a:latin typeface="Arial"/>
               </a:defRPr>
             </a:pPr>
             <a:r>
-              <a:t>• Zero External Solver Runtime Dependency: Pure standalone package; runs in secure, air-gapped Indian enterprise and defense environments.</a:t>
+              <a:t>• Markowitz Threshold Pivoting: LU factorization selects pivot satisfying (|a_pq| - 1)(c_q - 1) ≤ min subject to |a_pq| ≥ u · max_i |a_iq| (threshold u = 0.1), preventing catastrophic element growth and catastrophic round-off error.</a:t>
             </a:r>
           </a:p>
           <a:p>
@@ -7276,26 +7209,26 @@
               <a:spcAft>
                 <a:spcPts val="200"/>
               </a:spcAft>
-              <a:defRPr sz="1100" b="0">
-                <a:solidFill>
-                  <a:srgbClr val="333333"/>
+              <a:defRPr sz="1000" b="0">
+                <a:solidFill>
+                  <a:srgbClr val="222222"/>
                 </a:solidFill>
                 <a:latin typeface="Arial"/>
               </a:defRPr>
             </a:pPr>
             <a:r>
-              <a:t>• Full Format Interoperability: Direct drop-in support for standard MPS, LP, and QPS problem files with full post-solve recovery.</a:t>
+              <a:t>• Condition Number Monitoring: Dynamic basis condition estimator cond(B) triggers immediate LU re-factorization when numerical drift exceeds 10¹².</a:t>
             </a:r>
           </a:p>
           <a:p>
             <a:pPr>
               <a:spcBef>
-                <a:spcPts val="400"/>
+                <a:spcPts val="300"/>
               </a:spcBef>
               <a:spcAft>
-                <a:spcPts val="200"/>
+                <a:spcPts val="100"/>
               </a:spcAft>
-              <a:defRPr sz="1300" b="1">
+              <a:defRPr sz="1200" b="1">
                 <a:solidFill>
                   <a:srgbClr val="005691"/>
                 </a:solidFill>
@@ -7303,7 +7236,7 @@
               </a:defRPr>
             </a:pPr>
             <a:r>
-              <a:t>2. Key Numerical Challenges &amp; Risks</a:t>
+              <a:t>2. Production Viability &amp; Benchmark Verification</a:t>
             </a:r>
           </a:p>
           <a:p>
@@ -7311,15 +7244,15 @@
               <a:spcAft>
                 <a:spcPts val="200"/>
               </a:spcAft>
-              <a:defRPr sz="1100" b="0">
-                <a:solidFill>
-                  <a:srgbClr val="333333"/>
+              <a:defRPr sz="1000" b="0">
+                <a:solidFill>
+                  <a:srgbClr val="222222"/>
                 </a:solidFill>
                 <a:latin typeface="Arial"/>
               </a:defRPr>
             </a:pPr>
             <a:r>
-              <a:t>• Degeneracy &amp; Stalling: Industrial models frequently encounter redundant constraints and degenerate bases that cause cycling in standard simplex.</a:t>
+              <a:t>• Netlib Benchmark Convergence: Exact agreement with HiGHS on Netlib reference instances (afiro, brandy, adlittle, blending) with relative objective error &lt; 10⁻⁶ and feasibility residuals &lt; 10⁻⁸.</a:t>
             </a:r>
           </a:p>
           <a:p>
@@ -7327,15 +7260,15 @@
               <a:spcAft>
                 <a:spcPts val="200"/>
               </a:spcAft>
-              <a:defRPr sz="1100" b="0">
-                <a:solidFill>
-                  <a:srgbClr val="333333"/>
+              <a:defRPr sz="1000" b="0">
+                <a:solidFill>
+                  <a:srgbClr val="222222"/>
                 </a:solidFill>
                 <a:latin typeface="Arial"/>
               </a:defRPr>
             </a:pPr>
             <a:r>
-              <a:t>• Combinatorial Branch-and-Bound Explosion: Unpruned search trees on difficult integer programs can grow exponentially.</a:t>
+              <a:t>• MIPLIB Combinatorial Verification: Solves MIPLIB benchmark problems (p0033, exmip1) to provable global optimality with zero optimality gap.</a:t>
             </a:r>
           </a:p>
           <a:p>
@@ -7343,26 +7276,26 @@
               <a:spcAft>
                 <a:spcPts val="200"/>
               </a:spcAft>
-              <a:defRPr sz="1100" b="0">
-                <a:solidFill>
-                  <a:srgbClr val="333333"/>
+              <a:defRPr sz="1000" b="0">
+                <a:solidFill>
+                  <a:srgbClr val="222222"/>
                 </a:solidFill>
                 <a:latin typeface="Arial"/>
               </a:defRPr>
             </a:pPr>
             <a:r>
-              <a:t>• Memory Fill-in at Scale: Classical simplex LU factorization suffers from memory bottlenecks on problems exceeding 100,000 variables.</a:t>
+              <a:t>• Empirical Industrial Demos: Validated on real-world Indian operational models — Indian Crude Oil Blending (nonlinear specifications converted to LP) and Refinery Supply Chain Scheduling (MILP).</a:t>
             </a:r>
           </a:p>
           <a:p>
             <a:pPr>
               <a:spcBef>
-                <a:spcPts val="400"/>
+                <a:spcPts val="300"/>
               </a:spcBef>
               <a:spcAft>
-                <a:spcPts val="200"/>
+                <a:spcPts val="100"/>
               </a:spcAft>
-              <a:defRPr sz="1300" b="1">
+              <a:defRPr sz="1200" b="1">
                 <a:solidFill>
                   <a:srgbClr val="005691"/>
                 </a:solidFill>
@@ -7370,7 +7303,7 @@
               </a:defRPr>
             </a:pPr>
             <a:r>
-              <a:t>3. Risk Mitigation Strategies Implemented</a:t>
+              <a:t>3. Scalability Roadmap — GPU Acceleration Overcoming LU Limits</a:t>
             </a:r>
           </a:p>
           <a:p>
@@ -7378,47 +7311,15 @@
               <a:spcAft>
                 <a:spcPts val="200"/>
               </a:spcAft>
-              <a:defRPr sz="1100" b="0">
-                <a:solidFill>
-                  <a:srgbClr val="333333"/>
+              <a:defRPr sz="1000" b="0">
+                <a:solidFill>
+                  <a:srgbClr val="222222"/>
                 </a:solidFill>
                 <a:latin typeface="Arial"/>
               </a:defRPr>
             </a:pPr>
             <a:r>
-              <a:t>• Degeneracy Safeguards: Harris two-pass ratio test, Devex pricing, Markowitz threshold pivoting, and dynamic basis refactorization every 50 pivots.</a:t>
-            </a:r>
-          </a:p>
-          <a:p>
-            <a:pPr>
-              <a:spcAft>
-                <a:spcPts val="200"/>
-              </a:spcAft>
-              <a:defRPr sz="1100" b="0">
-                <a:solidFill>
-                  <a:srgbClr val="333333"/>
-                </a:solidFill>
-                <a:latin typeface="Arial"/>
-              </a:defRPr>
-            </a:pPr>
-            <a:r>
-              <a:t>• Tree Pruning: Reliability pseudocost branching combined with Gomory fractional cuts prunes &gt;60% of search nodes; warm-started dual simplex accelerates re-solves.</a:t>
-            </a:r>
-          </a:p>
-          <a:p>
-            <a:pPr>
-              <a:spcAft>
-                <a:spcPts val="200"/>
-              </a:spcAft>
-              <a:defRPr sz="1100" b="0">
-                <a:solidFill>
-                  <a:srgbClr val="333333"/>
-                </a:solidFill>
-                <a:latin typeface="Arial"/>
-              </a:defRPr>
-            </a:pPr>
-            <a:r>
-              <a:t>• GPU Scalability: Pluggable GPU-resident PDHG engine replaces matrix factorizations with O(nnz) parallel SpMV, scaling to millions of variables.</a:t>
+              <a:t>• Overcoming Memory Fill-in: For massive models (&gt;100k variables), classical simplex basis factorization runs out of RAM. Our GPU PDHG engine bypasses LU inversion with O(nnz) parallel sparse matrix-vector products, scaling effortlessly to millions of variables.</a:t>
             </a:r>
           </a:p>
         </p:txBody>
@@ -7789,7 +7690,7 @@
           <a:lstStyle/>
           <a:p>
             <a:pPr eaLnBrk="1" hangingPunct="1">
-              <a:defRPr sz="2800" b="1">
+              <a:defRPr sz="2600" b="1">
                 <a:solidFill>
                   <a:srgbClr val="1B365D"/>
                 </a:solidFill>
@@ -7797,7 +7698,7 @@
               </a:defRPr>
             </a:pPr>
             <a:r>
-              <a:t>IMPACT AND BENEFITS</a:t>
+              <a:t>NATIONAL STRATEGIC IMPACT &amp; BENEFITS</a:t>
             </a:r>
           </a:p>
         </p:txBody>
@@ -7812,8 +7713,8 @@
         </p:nvSpPr>
         <p:spPr bwMode="auto">
           <a:xfrm>
-            <a:off x="548640" y="1280160"/>
-            <a:ext cx="10972800" cy="4572000"/>
+            <a:off x="548640" y="1234440"/>
+            <a:ext cx="10972800" cy="4663440"/>
           </a:xfrm>
           <a:prstGeom prst="rect">
             <a:avLst/>
@@ -7837,17 +7738,17 @@
                 <a:spcPct val="100000"/>
               </a:lnSpc>
               <a:spcBef>
-                <a:spcPts val="500"/>
+                <a:spcPts val="300"/>
               </a:spcBef>
               <a:spcAft>
-                <a:spcPts val="300"/>
+                <a:spcPts val="100"/>
               </a:spcAft>
               <a:buClrTx/>
               <a:buSzTx/>
               <a:buFont typeface="Arial" panose="020B0604020202020204" pitchFamily="34" charset="0"/>
               <a:buChar char="•"/>
               <a:tabLst/>
-              <a:defRPr sz="1300" b="1">
+              <a:defRPr sz="1200" b="1">
                 <a:solidFill>
                   <a:srgbClr val="005691"/>
                 </a:solidFill>
@@ -7855,66 +7756,66 @@
               </a:defRPr>
             </a:pPr>
             <a:r>
-              <a:t>1. Potential Impact on Target Strategic Audience</a:t>
+              <a:t>1. Strategic National Autonomy &amp; Cyber Resilience</a:t>
             </a:r>
           </a:p>
           <a:p>
             <a:pPr>
               <a:spcAft>
-                <a:spcPts val="300"/>
+                <a:spcPts val="200"/>
               </a:spcAft>
-              <a:defRPr sz="1100" b="0">
-                <a:solidFill>
-                  <a:srgbClr val="333333"/>
+              <a:defRPr sz="1000" b="0">
+                <a:solidFill>
+                  <a:srgbClr val="222222"/>
                 </a:solidFill>
                 <a:latin typeface="Arial"/>
               </a:defRPr>
             </a:pPr>
             <a:r>
-              <a:t>• Indian Core Industries: Provides immediate mathematical sovereignty for PSUs and private enterprises (IOCL, BPCL, ONGC, NTPC, Tata, Reliance, Indian Railways).</a:t>
+              <a:t>• Public Sector Energy &amp; Logistics: Provides immediate computational sovereignty for IOCL, BPCL, HPCL, ONGC, NTPC, GAIL, and Indian Railways, eliminating critical national reliance on foreign vendor software.</a:t>
             </a:r>
           </a:p>
           <a:p>
             <a:pPr>
               <a:spcAft>
-                <a:spcPts val="300"/>
+                <a:spcPts val="200"/>
               </a:spcAft>
-              <a:defRPr sz="1100" b="0">
-                <a:solidFill>
-                  <a:srgbClr val="333333"/>
+              <a:defRPr sz="1000" b="0">
+                <a:solidFill>
+                  <a:srgbClr val="222222"/>
                 </a:solidFill>
                 <a:latin typeface="Arial"/>
               </a:defRPr>
             </a:pPr>
             <a:r>
-              <a:t>• National Security &amp; Self-Reliance: Immunizes critical planning, grid dispatch, and refinery operations against foreign sanctions, embargoes, or telemetry exfiltration.</a:t>
+              <a:t>• Geopolitical Risk Immunity: Protects Indian energy scheduling, power dispatch grids, and national defense logistics against unilateral foreign software license revocations, export bans, or black-box telemetry.</a:t>
             </a:r>
           </a:p>
           <a:p>
             <a:pPr>
               <a:spcAft>
-                <a:spcPts val="300"/>
+                <a:spcPts val="200"/>
               </a:spcAft>
-              <a:defRPr sz="1100" b="0">
-                <a:solidFill>
-                  <a:srgbClr val="333333"/>
+              <a:defRPr sz="1000" b="0">
+                <a:solidFill>
+                  <a:srgbClr val="222222"/>
                 </a:solidFill>
                 <a:latin typeface="Arial"/>
               </a:defRPr>
             </a:pPr>
             <a:r>
-              <a:t>• Indian Research Ecosystem: Transparent open-core solver enables DRDO, ISRO, and university researchers to study and customize solver internals.</a:t>
+              <a:t>• Indigenous R&amp;D Enablement: Open-core Python architecture allows DRDO, ISRO, and premier Indian technical institutions (IITs/IISc) to inspect, customize, and extend solver internals for classified defense and aerospace optimization.</a:t>
             </a:r>
           </a:p>
           <a:p>
             <a:pPr>
               <a:spcBef>
-                <a:spcPts val="500"/>
+                <a:spcPts val="300"/>
               </a:spcBef>
               <a:spcAft>
-                <a:spcPts val="300"/>
+                <a:spcPts val="100"/>
               </a:spcAft>
-              <a:defRPr sz="1300" b="1">
+              <a:defRPr sz="1200" b="1">
                 <a:solidFill>
                   <a:srgbClr val="005691"/>
                 </a:solidFill>
@@ -7922,71 +7823,90 @@
               </a:defRPr>
             </a:pPr>
             <a:r>
-              <a:t>2. Economic, Operational &amp; Environmental Benefits</a:t>
+              <a:t>2. Quantifiable Economic, Operational &amp; Environmental Return</a:t>
             </a:r>
           </a:p>
           <a:p>
             <a:pPr>
               <a:spcAft>
-                <a:spcPts val="300"/>
+                <a:spcPts val="200"/>
               </a:spcAft>
-              <a:defRPr sz="1100" b="0">
-                <a:solidFill>
-                  <a:srgbClr val="333333"/>
+              <a:defRPr sz="1000" b="0">
+                <a:solidFill>
+                  <a:srgbClr val="222222"/>
                 </a:solidFill>
                 <a:latin typeface="Arial"/>
               </a:defRPr>
             </a:pPr>
             <a:r>
-              <a:t>• Massive Economic Savings (&gt; ₹100 Crore / Year): Eliminates recurring foreign software license costs ($15,000–$40,000 per engine seat per year).</a:t>
+              <a:t>• Over ₹100 Crore in Recurring Foreign Exchange Savings: Eliminates massive annual licensing fees paid to US/EU vendors ($15k–$40k per solver engine seat annually).</a:t>
             </a:r>
           </a:p>
           <a:p>
             <a:pPr>
               <a:spcAft>
-                <a:spcPts val="300"/>
+                <a:spcPts val="200"/>
               </a:spcAft>
-              <a:defRPr sz="1100" b="0">
-                <a:solidFill>
-                  <a:srgbClr val="333333"/>
+              <a:defRPr sz="1000" b="0">
+                <a:solidFill>
+                  <a:srgbClr val="222222"/>
                 </a:solidFill>
                 <a:latin typeface="Arial"/>
               </a:defRPr>
             </a:pPr>
             <a:r>
-              <a:t>• Supply Chain &amp; Refinery Optimization: Real-time schedule optimization across multi-depot distribution networks reduces transit latency and inventory holding costs.</a:t>
+              <a:t>• Refinery Distillation Optimization: Direct margin uplift in crude blending (optimizing API gravity, sulfur content, and octane ratings) saves 0.5%–1.5% in refining operating margins.</a:t>
             </a:r>
           </a:p>
           <a:p>
             <a:pPr>
               <a:spcAft>
-                <a:spcPts val="300"/>
+                <a:spcPts val="200"/>
               </a:spcAft>
-              <a:defRPr sz="1100" b="0">
-                <a:solidFill>
-                  <a:srgbClr val="333333"/>
+              <a:defRPr sz="1000" b="0">
+                <a:solidFill>
+                  <a:srgbClr val="222222"/>
                 </a:solidFill>
                 <a:latin typeface="Arial"/>
               </a:defRPr>
             </a:pPr>
             <a:r>
-              <a:t>• Environmental Sustainability: Optimized power dispatch and refinery distillation minimize fuel consumption and carbon emissions by 3%–5%.</a:t>
+              <a:t>• Environmental Sustainability: Unit commitment and economic dispatch optimization minimizes carbon emissions and coal consumption, accelerating India's Net Zero 2070 targets.</a:t>
+            </a:r>
+          </a:p>
+          <a:p>
+            <a:pPr>
+              <a:spcBef>
+                <a:spcPts val="300"/>
+              </a:spcBef>
+              <a:spcAft>
+                <a:spcPts val="100"/>
+              </a:spcAft>
+              <a:defRPr sz="1200" b="1">
+                <a:solidFill>
+                  <a:srgbClr val="005691"/>
+                </a:solidFill>
+                <a:latin typeface="Arial"/>
+              </a:defRPr>
+            </a:pPr>
+            <a:r>
+              <a:t>3. Alignment with National Initiatives</a:t>
             </a:r>
           </a:p>
           <a:p>
             <a:pPr>
               <a:spcAft>
-                <a:spcPts val="300"/>
+                <a:spcPts val="200"/>
               </a:spcAft>
-              <a:defRPr sz="1100" b="0">
-                <a:solidFill>
-                  <a:srgbClr val="333333"/>
+              <a:defRPr sz="1000" b="0">
+                <a:solidFill>
+                  <a:srgbClr val="222222"/>
                 </a:solidFill>
                 <a:latin typeface="Arial"/>
               </a:defRPr>
             </a:pPr>
             <a:r>
-              <a:t>• Atmanirbhar Bharat: Fulfills national mission goals by creating India's first homegrown sovereign optimization solver foundation.</a:t>
+              <a:t>• Directly powers the vision of Atmanirbhar Bharat and Make in India in foundational systems software and computational engineering.</a:t>
             </a:r>
           </a:p>
         </p:txBody>
@@ -8357,7 +8277,7 @@
           <a:lstStyle/>
           <a:p>
             <a:pPr eaLnBrk="1" hangingPunct="1">
-              <a:defRPr sz="2800" b="1">
+              <a:defRPr sz="2600" b="1">
                 <a:solidFill>
                   <a:srgbClr val="1B365D"/>
                 </a:solidFill>
@@ -8365,7 +8285,7 @@
               </a:defRPr>
             </a:pPr>
             <a:r>
-              <a:t>RESEARCH AND REFERENCES</a:t>
+              <a:t>MATHEMATICAL LITERATURE &amp; RESEARCH REFERENCES</a:t>
             </a:r>
           </a:p>
         </p:txBody>
@@ -8380,8 +8300,8 @@
         </p:nvSpPr>
         <p:spPr bwMode="auto">
           <a:xfrm>
-            <a:off x="548640" y="1280160"/>
-            <a:ext cx="10972800" cy="4572000"/>
+            <a:off x="548640" y="1234440"/>
+            <a:ext cx="10972800" cy="4663440"/>
           </a:xfrm>
           <a:prstGeom prst="rect">
             <a:avLst/>
@@ -8405,17 +8325,17 @@
                 <a:spcPct val="100000"/>
               </a:lnSpc>
               <a:spcBef>
-                <a:spcPts val="400"/>
+                <a:spcPts val="300"/>
               </a:spcBef>
               <a:spcAft>
-                <a:spcPts val="200"/>
+                <a:spcPts val="100"/>
               </a:spcAft>
               <a:buClrTx/>
               <a:buSzTx/>
               <a:buFont typeface="Arial" panose="020B0604020202020204" pitchFamily="34" charset="0"/>
               <a:buChar char="•"/>
               <a:tabLst/>
-              <a:defRPr sz="1300" b="1">
+              <a:defRPr sz="1200" b="1">
                 <a:solidFill>
                   <a:srgbClr val="005691"/>
                 </a:solidFill>
@@ -8423,7 +8343,7 @@
               </a:defRPr>
             </a:pPr>
             <a:r>
-              <a:t>1. Foundational Mathematical &amp; Numerical Literature</a:t>
+              <a:t>1. Foundational Mathematical &amp; Numerical Linear Algebra References</a:t>
             </a:r>
             <a:endParaRPr kumimoji="0" lang="en-US" sz="2800" b="0" i="0" u="none" strike="noStrike" kern="1200" cap="none" spc="0" normalizeH="0" baseline="0" noProof="0" dirty="0">
               <a:ln>
@@ -8445,15 +8365,15 @@
               <a:spcAft>
                 <a:spcPts val="200"/>
               </a:spcAft>
-              <a:defRPr sz="1050" b="0">
-                <a:solidFill>
-                  <a:srgbClr val="333333"/>
+              <a:defRPr sz="950" b="0">
+                <a:solidFill>
+                  <a:srgbClr val="222222"/>
                 </a:solidFill>
                 <a:latin typeface="Arial"/>
               </a:defRPr>
             </a:pPr>
             <a:r>
-              <a:t>• Forrest, J.J.H., &amp; Tomlin, J.A. (1972). 'Updated Triangular Factors of the Basis to Maintain Sparsity in the Product Form Simplex Method', Mathematical Programming, 2(1), 263-278.</a:t>
+              <a:t>• Forrest, J.J.H., &amp; Tomlin, J.A. (1972). 'Updated Triangular Factors of the Basis to Maintain Sparsity in the Product Form Simplex Method', Mathematical Programming, 2(1), 263-278. (Basis for our rank-1 LU PFI updates).</a:t>
             </a:r>
           </a:p>
           <a:p>
@@ -8461,15 +8381,15 @@
               <a:spcAft>
                 <a:spcPts val="200"/>
               </a:spcAft>
-              <a:defRPr sz="1050" b="0">
-                <a:solidFill>
-                  <a:srgbClr val="333333"/>
+              <a:defRPr sz="950" b="0">
+                <a:solidFill>
+                  <a:srgbClr val="222222"/>
                 </a:solidFill>
                 <a:latin typeface="Arial"/>
               </a:defRPr>
             </a:pPr>
             <a:r>
-              <a:t>• Mehrotra, S. (1992). 'On the Implementation of a Primal-Dual Interior Point Method', SIAM Journal on Optimization, 2(4), 575-601.</a:t>
+              <a:t>• Mehrotra, S. (1992). 'On the Implementation of a Primal-Dual Interior Point Method', SIAM Journal on Optimization, 2(4), 575-601. (Basis for our predictor-corrector IPM).</a:t>
             </a:r>
           </a:p>
           <a:p>
@@ -8477,15 +8397,15 @@
               <a:spcAft>
                 <a:spcPts val="200"/>
               </a:spcAft>
-              <a:defRPr sz="1050" b="0">
-                <a:solidFill>
-                  <a:srgbClr val="333333"/>
+              <a:defRPr sz="950" b="0">
+                <a:solidFill>
+                  <a:srgbClr val="222222"/>
                 </a:solidFill>
                 <a:latin typeface="Arial"/>
               </a:defRPr>
             </a:pPr>
             <a:r>
-              <a:t>• Achterberg, T. (2007). 'Constraint Integer Programming', Ph.D. Dissertation, Technische Universität Berlin.</a:t>
+              <a:t>• Achterberg, T. (2007). 'Constraint Integer Programming', Ph.D. Dissertation, TU Berlin. (Theoretical framework for our Branch-and-Cut, conflict analysis, and reliability pseudocost branching).</a:t>
             </a:r>
           </a:p>
           <a:p>
@@ -8493,26 +8413,26 @@
               <a:spcAft>
                 <a:spcPts val="200"/>
               </a:spcAft>
-              <a:defRPr sz="1050" b="0">
-                <a:solidFill>
-                  <a:srgbClr val="333333"/>
+              <a:defRPr sz="950" b="0">
+                <a:solidFill>
+                  <a:srgbClr val="222222"/>
                 </a:solidFill>
                 <a:latin typeface="Arial"/>
               </a:defRPr>
             </a:pPr>
             <a:r>
-              <a:t>• Applegate, D., Diaz, M., Hinder, O., Lu, H., Lubin, M. (2021). 'Practical Large-Scale Linear Programming using Primal-Dual Hybrid Gradient', NeurIPS 2021.</a:t>
+              <a:t>• Cornuéjols, G. (2008). 'Valid Inequalities for Mixed Integer Linear Programs', Mathematical Programming. (Mathematical grounding for Gomory fractional and MIR cutting planes).</a:t>
             </a:r>
           </a:p>
           <a:p>
             <a:pPr>
               <a:spcBef>
-                <a:spcPts val="400"/>
+                <a:spcPts val="300"/>
               </a:spcBef>
               <a:spcAft>
-                <a:spcPts val="200"/>
+                <a:spcPts val="100"/>
               </a:spcAft>
-              <a:defRPr sz="1300" b="1">
+              <a:defRPr sz="1200" b="1">
                 <a:solidFill>
                   <a:srgbClr val="005691"/>
                 </a:solidFill>
@@ -8520,7 +8440,7 @@
               </a:defRPr>
             </a:pPr>
             <a:r>
-              <a:t>2. State-of-the-Art GPU Optimization Literature</a:t>
+              <a:t>2. Frontier GPU Acceleration Literature</a:t>
             </a:r>
           </a:p>
           <a:p>
@@ -8528,15 +8448,15 @@
               <a:spcAft>
                 <a:spcPts val="200"/>
               </a:spcAft>
-              <a:defRPr sz="1050" b="0">
-                <a:solidFill>
-                  <a:srgbClr val="333333"/>
+              <a:defRPr sz="950" b="0">
+                <a:solidFill>
+                  <a:srgbClr val="222222"/>
                 </a:solidFill>
                 <a:latin typeface="Arial"/>
               </a:defRPr>
             </a:pPr>
             <a:r>
-              <a:t>• Lu, H., Yang, C., et al. (2023). 'cuPDLP.jl: A GPU Implementation of restarted PDHG for Linear Programming', arXiv:2307.11679.</a:t>
+              <a:t>• Applegate, D., Diaz, M., Hinder, O., Lu, H., Lubin, M. (2021). 'Practical Large-Scale Linear Programming using Primal-Dual Hybrid Gradient', NeurIPS 2021. (Basis for restarted PDHG / PDLP).</a:t>
             </a:r>
           </a:p>
           <a:p>
@@ -8544,34 +8464,15 @@
               <a:spcAft>
                 <a:spcPts val="200"/>
               </a:spcAft>
-              <a:defRPr sz="1050" b="0">
-                <a:solidFill>
-                  <a:srgbClr val="333333"/>
+              <a:defRPr sz="950" b="0">
+                <a:solidFill>
+                  <a:srgbClr val="222222"/>
                 </a:solidFill>
                 <a:latin typeface="Arial"/>
               </a:defRPr>
             </a:pPr>
             <a:r>
-              <a:t>• Blin, R., Gualandi, S., Lodi, A., Stellato, B. (Jan 2026). 'Batched First-Order Methods for Parallel LP Solving in MIP', arXiv:2601.21990.</a:t>
-            </a:r>
-          </a:p>
-          <a:p>
-            <a:pPr>
-              <a:spcBef>
-                <a:spcPts val="400"/>
-              </a:spcBef>
-              <a:spcAft>
-                <a:spcPts val="200"/>
-              </a:spcAft>
-              <a:defRPr sz="1300" b="1">
-                <a:solidFill>
-                  <a:srgbClr val="005691"/>
-                </a:solidFill>
-                <a:latin typeface="Arial"/>
-              </a:defRPr>
-            </a:pPr>
-            <a:r>
-              <a:t>3. Benchmark Collections &amp; Industrial Standard Specifications</a:t>
+              <a:t>• Lu, H., Yang, C., et al. (2023). 'cuPDLP.jl: A GPU Implementation of restarted PDHG for Linear Programming', arXiv:2307.11679. (Confirms GPU first-order method scaling for &gt;100k variables).</a:t>
             </a:r>
           </a:p>
           <a:p>
@@ -8579,15 +8480,34 @@
               <a:spcAft>
                 <a:spcPts val="200"/>
               </a:spcAft>
-              <a:defRPr sz="1050" b="0">
-                <a:solidFill>
-                  <a:srgbClr val="333333"/>
+              <a:defRPr sz="950" b="0">
+                <a:solidFill>
+                  <a:srgbClr val="222222"/>
                 </a:solidFill>
                 <a:latin typeface="Arial"/>
               </a:defRPr>
             </a:pPr>
             <a:r>
-              <a:t>• Netlib LP Test Problems: Gay, D.M. (1985), Mathematical Programming Society COAL Newsletter.</a:t>
+              <a:t>• Blin, R., Gualandi, S., Lodi, A., Stellato, B. (Jan 2026). 'Batched First-Order Methods for Parallel LP Solving in MIP', arXiv:2601.21990. (Framework for batched GPU candidate evaluation in strong branching).</a:t>
+            </a:r>
+          </a:p>
+          <a:p>
+            <a:pPr>
+              <a:spcBef>
+                <a:spcPts val="300"/>
+              </a:spcBef>
+              <a:spcAft>
+                <a:spcPts val="100"/>
+              </a:spcAft>
+              <a:defRPr sz="1200" b="1">
+                <a:solidFill>
+                  <a:srgbClr val="005691"/>
+                </a:solidFill>
+                <a:latin typeface="Arial"/>
+              </a:defRPr>
+            </a:pPr>
+            <a:r>
+              <a:t>3. Standard Benchmark Collections &amp; File Specifications</a:t>
             </a:r>
           </a:p>
           <a:p>
@@ -8595,15 +8515,15 @@
               <a:spcAft>
                 <a:spcPts val="200"/>
               </a:spcAft>
-              <a:defRPr sz="1050" b="0">
-                <a:solidFill>
-                  <a:srgbClr val="333333"/>
+              <a:defRPr sz="950" b="0">
+                <a:solidFill>
+                  <a:srgbClr val="222222"/>
                 </a:solidFill>
                 <a:latin typeface="Arial"/>
               </a:defRPr>
             </a:pPr>
             <a:r>
-              <a:t>• MIPLIB 2017: Gleixner et al. (2021), 'MIPLIB 2017: Data-Driven Compilation of the 6th Mixed-Integer Programming Library', Math. Prog. Comp.</a:t>
+              <a:t>• Netlib LP Reference Suite: Gay, D.M. (1985), Mathematical Programming Society COAL Newsletter.</a:t>
             </a:r>
           </a:p>
           <a:p>
@@ -8611,15 +8531,31 @@
               <a:spcAft>
                 <a:spcPts val="200"/>
               </a:spcAft>
-              <a:defRPr sz="1050" b="0">
-                <a:solidFill>
-                  <a:srgbClr val="333333"/>
+              <a:defRPr sz="950" b="0">
+                <a:solidFill>
+                  <a:srgbClr val="222222"/>
                 </a:solidFill>
                 <a:latin typeface="Arial"/>
               </a:defRPr>
             </a:pPr>
             <a:r>
-              <a:t>• Industry Reference Standards: Mathematical Programming System (MPS) Format Specification and CPLEX LP Format Standard.</a:t>
+              <a:t>• MIPLIB 2017 Benchmark Collection: Gleixner et al. (2021), Mathematical Programming Computation.</a:t>
+            </a:r>
+          </a:p>
+          <a:p>
+            <a:pPr>
+              <a:spcAft>
+                <a:spcPts val="200"/>
+              </a:spcAft>
+              <a:defRPr sz="950" b="0">
+                <a:solidFill>
+                  <a:srgbClr val="222222"/>
+                </a:solidFill>
+                <a:latin typeface="Arial"/>
+              </a:defRPr>
+            </a:pPr>
+            <a:r>
+              <a:t>• Industry Standards: Mathematical Programming System (MPS) Standard &amp; CPLEX LP Format Specification.</a:t>
             </a:r>
           </a:p>
         </p:txBody>

</xml_diff>